<commit_message>
style: Refine tone and formatting to match 2025 entry sheet style
</commit_message>
<xml_diff>
--- a/md/zenjyocon_entry_sheet_2026.pptx
+++ b/md/zenjyocon_entry_sheet_2026.pptx
@@ -7859,937 +7859,7 @@
 </p:sldMaster>
 </file>
 
-<file path=ppt/slides/slide10.xml><?xml version="1.0" encoding="utf-8"?>
-<p:sld xmlns:a="http://schemas.openxmlformats.org/drawingml/2006/main" xmlns:r="http://schemas.openxmlformats.org/officeDocument/2006/relationships" xmlns:mc="http://schemas.openxmlformats.org/markup-compatibility/2006" xmlns:mv="urn:schemas-microsoft-com:mac:vml" xmlns:p="http://schemas.openxmlformats.org/presentationml/2006/main" xmlns:c="http://schemas.openxmlformats.org/drawingml/2006/chart" xmlns:dgm="http://schemas.openxmlformats.org/drawingml/2006/diagram" xmlns:o="urn:schemas-microsoft-com:office:office" xmlns:v="urn:schemas-microsoft-com:vml" xmlns:pvml="urn:schemas-microsoft-com:office:powerpoint" xmlns:com="http://schemas.openxmlformats.org/drawingml/2006/compatibility" xmlns:p14="http://schemas.microsoft.com/office/powerpoint/2010/main" xmlns:p15="http://schemas.microsoft.com/office/powerpoint/2012/main" xmlns:ahyp="http://schemas.microsoft.com/office/drawing/2018/hyperlinkcolor">
-  <p:cSld>
-    <p:spTree>
-      <p:nvGrpSpPr>
-        <p:cNvPr id="137" name="Shape 137"/>
-        <p:cNvGrpSpPr/>
-        <p:nvPr/>
-      </p:nvGrpSpPr>
-      <p:grpSpPr>
-        <a:xfrm>
-          <a:off x="0" y="0"/>
-          <a:ext cx="0" cy="0"/>
-          <a:chOff x="0" y="0"/>
-          <a:chExt cx="0" cy="0"/>
-        </a:xfrm>
-      </p:grpSpPr>
-      <p:sp>
-        <p:nvSpPr>
-          <p:cNvPr id="138" name="Google Shape;138;p24"/>
-          <p:cNvSpPr txBox="1"/>
-          <p:nvPr/>
-        </p:nvSpPr>
-        <p:spPr>
-          <a:xfrm>
-            <a:off x="393700" y="276225"/>
-            <a:ext cx="7223252" cy="257758"/>
-          </a:xfrm>
-          <a:prstGeom prst="rect">
-            <a:avLst/>
-          </a:prstGeom>
-          <a:noFill/>
-          <a:ln>
-            <a:noFill/>
-          </a:ln>
-        </p:spPr>
-        <p:txBody>
-          <a:bodyPr anchorCtr="0" anchor="t" bIns="0" lIns="0" spcFirstLastPara="1" rIns="0" wrap="square" tIns="11425">
-            <a:spAutoFit/>
-          </a:bodyPr>
-          <a:lstStyle/>
-          <a:p>
-            <a:pPr indent="0" lvl="0" marL="12700" marR="0" rtl="0" algn="l">
-              <a:lnSpc>
-                <a:spcPct val="100000"/>
-              </a:lnSpc>
-              <a:spcBef>
-                <a:spcPts val="0"/>
-              </a:spcBef>
-              <a:spcAft>
-                <a:spcPts val="0"/>
-              </a:spcAft>
-              <a:buNone/>
-            </a:pPr>
-            <a:r>
-              <a:rPr b="1" i="0" lang="ja-JP" sz="1600" u="none" cap="none" strike="noStrike">
-                <a:solidFill>
-                  <a:schemeClr val="dk1"/>
-                </a:solidFill>
-                <a:latin typeface="Meiryo"/>
-                <a:ea typeface="Meiryo"/>
-                <a:cs typeface="Meiryo"/>
-                <a:sym typeface="Meiryo"/>
-              </a:rPr>
-              <a:t>作品詳細⑦（使いやすさと見せ方の工夫）　</a:t>
-            </a:r>
-            <a:endParaRPr b="1" i="0" sz="1600" u="none" cap="none" strike="noStrike">
-              <a:solidFill>
-                <a:schemeClr val="dk1"/>
-              </a:solidFill>
-              <a:latin typeface="Meiryo"/>
-              <a:ea typeface="Meiryo"/>
-              <a:cs typeface="Meiryo"/>
-              <a:sym typeface="Meiryo"/>
-            </a:endParaRPr>
-          </a:p>
-        </p:txBody>
-      </p:sp>
-      <p:sp>
-        <p:nvSpPr>
-          <p:cNvPr id="140" name="Google Shape;140;p24"/>
-          <p:cNvSpPr txBox="1"/>
-          <p:nvPr/>
-        </p:nvSpPr>
-        <p:spPr>
-          <a:xfrm>
-            <a:off x="475996" y="1049986"/>
-            <a:ext cx="8778240" cy="5029200"/>
-          </a:xfrm>
-          <a:prstGeom prst="rect">
-            <a:avLst/>
-          </a:prstGeom>
-          <a:noFill/>
-          <a:ln>
-            <a:noFill/>
-          </a:ln>
-        </p:spPr>
-        <p:txBody>
-          <a:bodyPr anchorCtr="0" anchor="t" bIns="45700" lIns="91425" spcFirstLastPara="1" rIns="91425" wrap="square" tIns="45700">
-            <a:spAutoFit/>
-          </a:bodyPr>
-          <a:lstStyle/>
-          <a:p>
-            <a:pPr indent="-285750" lvl="0" marL="285750" marR="0" rtl="0" algn="l">
-              <a:lnSpc>
-                <a:spcPct val="100000"/>
-              </a:lnSpc>
-              <a:spcBef>
-                <a:spcPts val="0"/>
-              </a:spcBef>
-              <a:spcAft>
-                <a:spcPts val="0"/>
-              </a:spcAft>
-              <a:buClr>
-                <a:srgbClr val="000000"/>
-              </a:buClr>
-              <a:buSzPts val="1400"/>
-              <a:buFont typeface="Noto Sans Symbols"/>
-              <a:buChar char="■"/>
-            </a:pPr>
-            <a:r>
-              <a:rPr sz="1200" b="1">
-                <a:solidFill>
-                  <a:srgbClr val="0F172A"/>
-                </a:solidFill>
-                <a:latin typeface="Hiragino Sans"/>
-              </a:rPr>
-              <a:t>■ 使いやすさと見せ方の工夫（UX/UI・アクセシビリティ・直感的なトラスト体験）【必須】</a:t>
-            </a:r>
-            <a:endParaRPr/>
-          </a:p>
-          <a:p>
-            <a:r>
-              <a:rPr sz="400" b="0">
-                <a:latin typeface="Hiragino Sans"/>
-              </a:rPr>
-              <a:t/>
-            </a:r>
-          </a:p>
-          <a:p>
-            <a:r>
-              <a:rPr sz="1100" b="1">
-                <a:solidFill>
-                  <a:srgbClr val="10B981"/>
-                </a:solidFill>
-                <a:latin typeface="Hiragino Sans"/>
-              </a:rPr>
-              <a:t>①【暗号やAIの専門知識がゼロでも1秒で安心できる「信号機＆ワンタップ数学的トラストUI」】</a:t>
-            </a:r>
-          </a:p>
-          <a:p>
-            <a:r>
-              <a:rPr sz="1000" b="0">
-                <a:solidFill>
-                  <a:srgbClr val="1E293B"/>
-                </a:solidFill>
-                <a:latin typeface="Hiragino Sans"/>
-              </a:rPr>
-              <a:t>ゼロ知識証明(ZKP)や完全準同型暗号(vFHE)、墨塗署名(DCSS)といった高度な数学的処理を裏側で完全に自動化。買い物客のスマホ画面や店舗タブレットには、数式ではなく「✓ アレルゲン基準クリア（小麦不使用を確認）」「✓ 個人情報マスク完了」「✓ 正規商品テーブル(LUT)比較証明済み」という直感的なグリーンバッジと、根拠となった棚写真のハイライト枠（image_bbox Locator）だけを表示する。</a:t>
-            </a:r>
-          </a:p>
-          <a:p>
-            <a:r>
-              <a:rPr sz="500" b="0">
-                <a:latin typeface="Hiragino Sans"/>
-              </a:rPr>
-              <a:t/>
-            </a:r>
-          </a:p>
-          <a:p>
-            <a:r>
-              <a:rPr sz="1100" b="1">
-                <a:solidFill>
-                  <a:srgbClr val="10B981"/>
-                </a:solidFill>
-                <a:latin typeface="Hiragino Sans"/>
-              </a:rPr>
-              <a:t>②【現場スタッフや高齢者の負担をゼロにする「3分岐オートメーション（自動承認／確認／拒否）」】</a:t>
-            </a:r>
-          </a:p>
-          <a:p>
-            <a:r>
-              <a:rPr sz="1000" b="0">
-                <a:solidFill>
-                  <a:srgbClr val="1E293B"/>
-                </a:solidFill>
-                <a:latin typeface="Hiragino Sans"/>
-              </a:rPr>
-              <a:t>すべての操作に人間の確認を求めると現場がパンクするため、OP-TEE内のポリシー照合により「通常の予算・安全基準内のピッキングは100%自動署名（平均670ms・操作不要）」、「品切れで代替品を提案する場合や予算超過時のみスマホへ分かりやすい比較カードで通知（確認）」、「不正な命令や危険動作は自動遮断（拒否）」の3段階に整理し、迷わない操作性を実現した。</a:t>
-            </a:r>
-          </a:p>
-          <a:p>
-            <a:r>
-              <a:rPr sz="500" b="0">
-                <a:latin typeface="Hiragino Sans"/>
-              </a:rPr>
-              <a:t/>
-            </a:r>
-          </a:p>
-          <a:p>
-            <a:r>
-              <a:rPr sz="1100" b="1">
-                <a:solidFill>
-                  <a:srgbClr val="10B981"/>
-                </a:solidFill>
-                <a:latin typeface="Hiragino Sans"/>
-              </a:rPr>
-              <a:t>③【4者のステークホルダー（お客様・店舗・ロボ開発者・損保/監査人）に合わせた専用ビュー切替】</a:t>
-            </a:r>
-          </a:p>
-          <a:p>
-            <a:r>
-              <a:rPr sz="1000" b="0">
-                <a:solidFill>
-                  <a:srgbClr val="1E293B"/>
-                </a:solidFill>
-                <a:latin typeface="Hiragino Sans"/>
-              </a:rPr>
-              <a:t>統合ダッシュボード（whiteboard.html）では、ドロップダウン1つで「自分が知りたいレイヤ」だけをハイライト表示できるフィルター機能と、平時の「墨塗り公開監査モード」から有事の「3-of-5閾値復号モード」への切り替えモックを備え、審査員や導入店舗が全体像から細部の数理仕様まで迷わず理解できる設計とした。</a:t>
-            </a:r>
-          </a:p>
-        </p:txBody>
-      </p:sp>
-      <p:sp>
-        <p:nvSpPr>
-          <p:cNvPr id="141" name="Google Shape;141;p24"/>
-          <p:cNvSpPr txBox="1"/>
-          <p:nvPr>
-            <p:ph idx="12" type="sldNum"/>
-          </p:nvPr>
-        </p:nvSpPr>
-        <p:spPr>
-          <a:xfrm>
-            <a:off x="3974306" y="7194550"/>
-            <a:ext cx="2743200" cy="365125"/>
-          </a:xfrm>
-          <a:prstGeom prst="rect">
-            <a:avLst/>
-          </a:prstGeom>
-          <a:noFill/>
-          <a:ln>
-            <a:noFill/>
-          </a:ln>
-        </p:spPr>
-        <p:txBody>
-          <a:bodyPr anchorCtr="0" anchor="ctr" bIns="45700" lIns="91425" spcFirstLastPara="1" rIns="91425" wrap="square" tIns="45700">
-            <a:noAutofit/>
-          </a:bodyPr>
-          <a:lstStyle/>
-          <a:p>
-            <a:pPr indent="0" lvl="0" marL="0" rtl="0" algn="ctr">
-              <a:lnSpc>
-                <a:spcPct val="100000"/>
-              </a:lnSpc>
-              <a:spcBef>
-                <a:spcPts val="0"/>
-              </a:spcBef>
-              <a:spcAft>
-                <a:spcPts val="0"/>
-              </a:spcAft>
-              <a:buSzPts val="700"/>
-              <a:buNone/>
-            </a:pPr>
-            <a:fld id="{00000000-1234-1234-1234-123412341234}" type="slidenum">
-              <a:rPr lang="ja-JP"/>
-              <a:t>‹#›</a:t>
-            </a:fld>
-            <a:endParaRPr/>
-          </a:p>
-        </p:txBody>
-      </p:sp>
-    </p:spTree>
-  </p:cSld>
-  <p:clrMapOvr>
-    <a:masterClrMapping/>
-  </p:clrMapOvr>
-</p:sld>
-</file>
-
-<file path=ppt/slides/slide11.xml><?xml version="1.0" encoding="utf-8"?>
-<p:sld xmlns:a="http://schemas.openxmlformats.org/drawingml/2006/main" xmlns:r="http://schemas.openxmlformats.org/officeDocument/2006/relationships" xmlns:mc="http://schemas.openxmlformats.org/markup-compatibility/2006" xmlns:mv="urn:schemas-microsoft-com:mac:vml" xmlns:p="http://schemas.openxmlformats.org/presentationml/2006/main" xmlns:c="http://schemas.openxmlformats.org/drawingml/2006/chart" xmlns:dgm="http://schemas.openxmlformats.org/drawingml/2006/diagram" xmlns:o="urn:schemas-microsoft-com:office:office" xmlns:v="urn:schemas-microsoft-com:vml" xmlns:pvml="urn:schemas-microsoft-com:office:powerpoint" xmlns:com="http://schemas.openxmlformats.org/drawingml/2006/compatibility" xmlns:p14="http://schemas.microsoft.com/office/powerpoint/2010/main" xmlns:p15="http://schemas.microsoft.com/office/powerpoint/2012/main" xmlns:ahyp="http://schemas.microsoft.com/office/drawing/2018/hyperlinkcolor">
-  <p:cSld>
-    <p:spTree>
-      <p:nvGrpSpPr>
-        <p:cNvPr id="145" name="Shape 145"/>
-        <p:cNvGrpSpPr/>
-        <p:nvPr/>
-      </p:nvGrpSpPr>
-      <p:grpSpPr>
-        <a:xfrm>
-          <a:off x="0" y="0"/>
-          <a:ext cx="0" cy="0"/>
-          <a:chOff x="0" y="0"/>
-          <a:chExt cx="0" cy="0"/>
-        </a:xfrm>
-      </p:grpSpPr>
-      <p:sp>
-        <p:nvSpPr>
-          <p:cNvPr id="146" name="Google Shape;146;p25"/>
-          <p:cNvSpPr txBox="1"/>
-          <p:nvPr/>
-        </p:nvSpPr>
-        <p:spPr>
-          <a:xfrm>
-            <a:off x="393700" y="276225"/>
-            <a:ext cx="7223252" cy="257758"/>
-          </a:xfrm>
-          <a:prstGeom prst="rect">
-            <a:avLst/>
-          </a:prstGeom>
-          <a:noFill/>
-          <a:ln>
-            <a:noFill/>
-          </a:ln>
-        </p:spPr>
-        <p:txBody>
-          <a:bodyPr anchorCtr="0" anchor="t" bIns="0" lIns="0" spcFirstLastPara="1" rIns="0" wrap="square" tIns="11425">
-            <a:spAutoFit/>
-          </a:bodyPr>
-          <a:lstStyle/>
-          <a:p>
-            <a:pPr indent="0" lvl="0" marL="12700" marR="0" rtl="0" algn="l">
-              <a:lnSpc>
-                <a:spcPct val="100000"/>
-              </a:lnSpc>
-              <a:spcBef>
-                <a:spcPts val="0"/>
-              </a:spcBef>
-              <a:spcAft>
-                <a:spcPts val="0"/>
-              </a:spcAft>
-              <a:buNone/>
-            </a:pPr>
-            <a:r>
-              <a:rPr b="1" i="0" lang="ja-JP" sz="1600" u="none" cap="none" strike="noStrike">
-                <a:solidFill>
-                  <a:schemeClr val="dk1"/>
-                </a:solidFill>
-                <a:latin typeface="Meiryo"/>
-                <a:ea typeface="Meiryo"/>
-                <a:cs typeface="Meiryo"/>
-                <a:sym typeface="Meiryo"/>
-              </a:rPr>
-              <a:t>作品詳細⑧（探究のプロセス）　</a:t>
-            </a:r>
-            <a:endParaRPr b="1" i="0" sz="1600" u="none" cap="none" strike="noStrike">
-              <a:solidFill>
-                <a:schemeClr val="dk1"/>
-              </a:solidFill>
-              <a:latin typeface="Meiryo"/>
-              <a:ea typeface="Meiryo"/>
-              <a:cs typeface="Meiryo"/>
-              <a:sym typeface="Meiryo"/>
-            </a:endParaRPr>
-          </a:p>
-        </p:txBody>
-      </p:sp>
-      <p:sp>
-        <p:nvSpPr>
-          <p:cNvPr id="148" name="Google Shape;148;p25"/>
-          <p:cNvSpPr txBox="1"/>
-          <p:nvPr/>
-        </p:nvSpPr>
-        <p:spPr>
-          <a:xfrm>
-            <a:off x="499443" y="1053169"/>
-            <a:ext cx="8778240" cy="5120640"/>
-          </a:xfrm>
-          <a:prstGeom prst="rect">
-            <a:avLst/>
-          </a:prstGeom>
-          <a:noFill/>
-          <a:ln>
-            <a:noFill/>
-          </a:ln>
-        </p:spPr>
-        <p:txBody>
-          <a:bodyPr anchorCtr="0" anchor="t" bIns="45700" lIns="91425" spcFirstLastPara="1" rIns="91425" wrap="square" tIns="45700">
-            <a:spAutoFit/>
-          </a:bodyPr>
-          <a:lstStyle/>
-          <a:p>
-            <a:pPr indent="-285750" lvl="0" marL="285750" marR="0" rtl="0" algn="l">
-              <a:lnSpc>
-                <a:spcPct val="100000"/>
-              </a:lnSpc>
-              <a:spcBef>
-                <a:spcPts val="0"/>
-              </a:spcBef>
-              <a:spcAft>
-                <a:spcPts val="0"/>
-              </a:spcAft>
-              <a:buClr>
-                <a:srgbClr val="000000"/>
-              </a:buClr>
-              <a:buSzPts val="1400"/>
-              <a:buFont typeface="Noto Sans Symbols"/>
-              <a:buChar char="■"/>
-            </a:pPr>
-            <a:r>
-              <a:rPr sz="1100" b="1">
-                <a:solidFill>
-                  <a:srgbClr val="0F172A"/>
-                </a:solidFill>
-                <a:latin typeface="Hiragino Sans"/>
-              </a:rPr>
-              <a:t>■ 最初の「もやもや」はどんなものでしたか？【必須】</a:t>
-            </a:r>
-            <a:endParaRPr/>
-          </a:p>
-          <a:p>
-            <a:r>
-              <a:rPr sz="950" b="0">
-                <a:solidFill>
-                  <a:srgbClr val="1E293B"/>
-                </a:solidFill>
-                <a:latin typeface="Hiragino Sans"/>
-              </a:rPr>
-              <a:t>街や飲食店で配膳・清掃ロボットを見かけるようになったが、「もしスーパーで買い物ロボットが棚の意地悪なPOP広告に騙されて違う商品を取ったら？」「子どもや家具にぶつかった時、AIのバグなのか不可抗力なのか誰も証明できないし、カメラ映像が管理者に筒抜けになるのも怖い。これでは保険にも入れず普及しないのでは？」という疑問からスタートした。</a:t>
-            </a:r>
-          </a:p>
-          <a:p>
-            <a:r>
-              <a:rPr sz="300" b="0">
-                <a:latin typeface="Hiragino Sans"/>
-              </a:rPr>
-              <a:t/>
-            </a:r>
-          </a:p>
-          <a:p>
-            <a:r>
-              <a:rPr sz="1100" b="1">
-                <a:solidFill>
-                  <a:srgbClr val="0F172A"/>
-                </a:solidFill>
-                <a:latin typeface="Hiragino Sans"/>
-              </a:rPr>
-              <a:t>■ 調べたこと・試してみたことはなんですか？【必須】</a:t>
-            </a:r>
-          </a:p>
-          <a:p>
-            <a:r>
-              <a:rPr sz="950" b="0">
-                <a:solidFill>
-                  <a:srgbClr val="1E293B"/>
-                </a:solidFill>
-                <a:latin typeface="Hiragino Sans"/>
-              </a:rPr>
-              <a:t>①高機能暗号プログラム（Advanced Cryptography Program）でのグループ議論（手書きホワイトボード：image copy.png）を通じ、AIエージェントの運用実績(task, trace)を顧客機密を渡さずに損保会社へ証明する「AIエージェント保険」と「Verifiable FHE (ZK+FHE)」を設計・試作した。</a:t>
-            </a:r>
-          </a:p>
-          <a:p>
-            <a:r>
-              <a:rPr sz="950" b="0">
-                <a:solidFill>
-                  <a:srgbClr val="1E293B"/>
-                </a:solidFill>
-                <a:latin typeface="Hiragino Sans"/>
-              </a:rPr>
-              <a:t>②さらにコンピュータセキュリティシンポジウム2026（CSS2026）の最新論文集を調査し、プロンプトインジェクション防御（ASIDE+ICA）、Random Forest分岐器によるトリアージ、VLAモデルの単一時刻摂動と動的Action Chunking、証跡Locatorの決定論的Lint、指定確認者墨塗署名（DCSS）の知見を検証・統合した。</a:t>
-            </a:r>
-          </a:p>
-          <a:p>
-            <a:r>
-              <a:rPr sz="300" b="0">
-                <a:latin typeface="Hiragino Sans"/>
-              </a:rPr>
-              <a:t/>
-            </a:r>
-          </a:p>
-          <a:p>
-            <a:r>
-              <a:rPr sz="1100" b="1">
-                <a:solidFill>
-                  <a:srgbClr val="0F172A"/>
-                </a:solidFill>
-                <a:latin typeface="Hiragino Sans"/>
-              </a:rPr>
-              <a:t>■ 得られた気づき（変化の瞬間）【必須】</a:t>
-            </a:r>
-          </a:p>
-          <a:p>
-            <a:r>
-              <a:rPr sz="950" b="0">
-                <a:solidFill>
-                  <a:srgbClr val="1E293B"/>
-                </a:solidFill>
-                <a:latin typeface="Hiragino Sans"/>
-              </a:rPr>
-              <a:t>最初は「全部を大型LLMとフルZK証明で処理しよう」としたが、実は①LLMに全部投げると遅延とコストが膨大になり、プロンプトだけで安全制約を書いても40%の要求超過が残ること、②FHEやZKは全工程にかけると重すぎること、③そして何より「スーパー側がロボットを購入・維持管理すること自体がビジネス上無理であり、AI企業もモデルの革新的な重み(知財)を監査で見せたくない」という現実の壁に気づいた。</a:t>
-            </a:r>
-          </a:p>
-          <a:p>
-            <a:r>
-              <a:rPr sz="300" b="0">
-                <a:latin typeface="Hiragino Sans"/>
-              </a:rPr>
-              <a:t/>
-            </a:r>
-          </a:p>
-          <a:p>
-            <a:r>
-              <a:rPr sz="1100" b="1">
-                <a:solidFill>
-                  <a:srgbClr val="0F172A"/>
-                </a:solidFill>
-                <a:latin typeface="Hiragino Sans"/>
-              </a:rPr>
-              <a:t>■ 問いがどう変わったか【必須】</a:t>
-            </a:r>
-          </a:p>
-          <a:p>
-            <a:r>
-              <a:rPr sz="950" b="0">
-                <a:solidFill>
-                  <a:srgbClr val="1E293B"/>
-                </a:solidFill>
-                <a:latin typeface="Hiragino Sans"/>
-              </a:rPr>
-              <a:t>単なる「賢いロボットを作る」という問いから、【店・物流倉庫は「ロボットを置ける場とZK検証インフラ（実行基盤）」だけを提供し、外部のロボットが「モデルの革新的知財と個人情報を隠したまま、ルックアップで何と比較検討したかを数学的に証明」してインセンティブを得る資本経済プラットフォームをどう作るか？】へと進化した。</a:t>
-            </a:r>
-          </a:p>
-          <a:p>
-            <a:r>
-              <a:rPr sz="300" b="0">
-                <a:latin typeface="Hiragino Sans"/>
-              </a:rPr>
-              <a:t/>
-            </a:r>
-          </a:p>
-          <a:p>
-            <a:r>
-              <a:rPr sz="1100" b="1">
-                <a:solidFill>
-                  <a:srgbClr val="0F172A"/>
-                </a:solidFill>
-                <a:latin typeface="Hiragino Sans"/>
-              </a:rPr>
-              <a:t>■ 次にやってみたいこと【必須】</a:t>
-            </a:r>
-          </a:p>
-          <a:p>
-            <a:r>
-              <a:rPr sz="950" b="0">
-                <a:solidFill>
-                  <a:srgbClr val="1E293B"/>
-                </a:solidFill>
-                <a:latin typeface="Hiragino Sans"/>
-              </a:rPr>
-              <a:t>今回構築したオープン実行基盤・標準モデル・ピックアップモックを実店舗および地域の物流倉庫のテストコースで長期稼働させ、複数ロボット間のP2Pリソース融通（バッテリー・通路渋滞情報）と実損保会社との約款連携実証を行いたい。</a:t>
-            </a:r>
-          </a:p>
-        </p:txBody>
-      </p:sp>
-      <p:sp>
-        <p:nvSpPr>
-          <p:cNvPr id="149" name="Google Shape;149;p25"/>
-          <p:cNvSpPr txBox="1"/>
-          <p:nvPr>
-            <p:ph idx="12" type="sldNum"/>
-          </p:nvPr>
-        </p:nvSpPr>
-        <p:spPr>
-          <a:xfrm>
-            <a:off x="3974306" y="7194550"/>
-            <a:ext cx="2743200" cy="365125"/>
-          </a:xfrm>
-          <a:prstGeom prst="rect">
-            <a:avLst/>
-          </a:prstGeom>
-          <a:noFill/>
-          <a:ln>
-            <a:noFill/>
-          </a:ln>
-        </p:spPr>
-        <p:txBody>
-          <a:bodyPr anchorCtr="0" anchor="ctr" bIns="45700" lIns="91425" spcFirstLastPara="1" rIns="91425" wrap="square" tIns="45700">
-            <a:noAutofit/>
-          </a:bodyPr>
-          <a:lstStyle/>
-          <a:p>
-            <a:pPr indent="0" lvl="0" marL="0" rtl="0" algn="ctr">
-              <a:lnSpc>
-                <a:spcPct val="100000"/>
-              </a:lnSpc>
-              <a:spcBef>
-                <a:spcPts val="0"/>
-              </a:spcBef>
-              <a:spcAft>
-                <a:spcPts val="0"/>
-              </a:spcAft>
-              <a:buSzPts val="700"/>
-              <a:buNone/>
-            </a:pPr>
-            <a:fld id="{00000000-1234-1234-1234-123412341234}" type="slidenum">
-              <a:rPr lang="ja-JP"/>
-              <a:t>‹#›</a:t>
-            </a:fld>
-            <a:endParaRPr/>
-          </a:p>
-        </p:txBody>
-      </p:sp>
-    </p:spTree>
-  </p:cSld>
-  <p:clrMapOvr>
-    <a:masterClrMapping/>
-  </p:clrMapOvr>
-</p:sld>
-</file>
-
-<file path=ppt/slides/slide12.xml><?xml version="1.0" encoding="utf-8"?>
-<p:sld xmlns:a="http://schemas.openxmlformats.org/drawingml/2006/main" xmlns:r="http://schemas.openxmlformats.org/officeDocument/2006/relationships" xmlns:mc="http://schemas.openxmlformats.org/markup-compatibility/2006" xmlns:mv="urn:schemas-microsoft-com:mac:vml" xmlns:p="http://schemas.openxmlformats.org/presentationml/2006/main" xmlns:c="http://schemas.openxmlformats.org/drawingml/2006/chart" xmlns:dgm="http://schemas.openxmlformats.org/drawingml/2006/diagram" xmlns:o="urn:schemas-microsoft-com:office:office" xmlns:v="urn:schemas-microsoft-com:vml" xmlns:pvml="urn:schemas-microsoft-com:office:powerpoint" xmlns:com="http://schemas.openxmlformats.org/drawingml/2006/compatibility" xmlns:p14="http://schemas.microsoft.com/office/powerpoint/2010/main" xmlns:p15="http://schemas.microsoft.com/office/powerpoint/2012/main" xmlns:ahyp="http://schemas.microsoft.com/office/drawing/2018/hyperlinkcolor">
-  <p:cSld>
-    <p:spTree>
-      <p:nvGrpSpPr>
-        <p:cNvPr id="153" name="Shape 153"/>
-        <p:cNvGrpSpPr/>
-        <p:nvPr/>
-      </p:nvGrpSpPr>
-      <p:grpSpPr>
-        <a:xfrm>
-          <a:off x="0" y="0"/>
-          <a:ext cx="0" cy="0"/>
-          <a:chOff x="0" y="0"/>
-          <a:chExt cx="0" cy="0"/>
-        </a:xfrm>
-      </p:grpSpPr>
-      <p:sp>
-        <p:nvSpPr>
-          <p:cNvPr id="154" name="Google Shape;154;p26"/>
-          <p:cNvSpPr txBox="1"/>
-          <p:nvPr/>
-        </p:nvSpPr>
-        <p:spPr>
-          <a:xfrm>
-            <a:off x="393700" y="276225"/>
-            <a:ext cx="7223252" cy="257758"/>
-          </a:xfrm>
-          <a:prstGeom prst="rect">
-            <a:avLst/>
-          </a:prstGeom>
-          <a:noFill/>
-          <a:ln>
-            <a:noFill/>
-          </a:ln>
-        </p:spPr>
-        <p:txBody>
-          <a:bodyPr anchorCtr="0" anchor="t" bIns="0" lIns="0" spcFirstLastPara="1" rIns="0" wrap="square" tIns="11425">
-            <a:spAutoFit/>
-          </a:bodyPr>
-          <a:lstStyle/>
-          <a:p>
-            <a:pPr indent="0" lvl="0" marL="12700" marR="0" rtl="0" algn="l">
-              <a:lnSpc>
-                <a:spcPct val="100000"/>
-              </a:lnSpc>
-              <a:spcBef>
-                <a:spcPts val="0"/>
-              </a:spcBef>
-              <a:spcAft>
-                <a:spcPts val="0"/>
-              </a:spcAft>
-              <a:buNone/>
-            </a:pPr>
-            <a:r>
-              <a:rPr b="1" i="0" lang="ja-JP" sz="1600" u="none" cap="none" strike="noStrike">
-                <a:solidFill>
-                  <a:schemeClr val="dk1"/>
-                </a:solidFill>
-                <a:latin typeface="Meiryo"/>
-                <a:ea typeface="Meiryo"/>
-                <a:cs typeface="Meiryo"/>
-                <a:sym typeface="Meiryo"/>
-              </a:rPr>
-              <a:t>作品詳細⑨（倫理・法的遵守）　</a:t>
-            </a:r>
-            <a:endParaRPr b="1" i="0" sz="1600" u="none" cap="none" strike="noStrike">
-              <a:solidFill>
-                <a:schemeClr val="dk1"/>
-              </a:solidFill>
-              <a:latin typeface="Meiryo"/>
-              <a:ea typeface="Meiryo"/>
-              <a:cs typeface="Meiryo"/>
-              <a:sym typeface="Meiryo"/>
-            </a:endParaRPr>
-          </a:p>
-        </p:txBody>
-      </p:sp>
-      <p:sp>
-        <p:nvSpPr>
-          <p:cNvPr id="156" name="Google Shape;156;p26"/>
-          <p:cNvSpPr txBox="1"/>
-          <p:nvPr/>
-        </p:nvSpPr>
-        <p:spPr>
-          <a:xfrm>
-            <a:off x="452549" y="1186610"/>
-            <a:ext cx="8778240" cy="5120640"/>
-          </a:xfrm>
-          <a:prstGeom prst="rect">
-            <a:avLst/>
-          </a:prstGeom>
-          <a:noFill/>
-          <a:ln>
-            <a:noFill/>
-          </a:ln>
-        </p:spPr>
-        <p:txBody>
-          <a:bodyPr anchorCtr="0" anchor="t" bIns="45700" lIns="91425" spcFirstLastPara="1" rIns="91425" wrap="square" tIns="45700">
-            <a:spAutoFit/>
-          </a:bodyPr>
-          <a:lstStyle/>
-          <a:p>
-            <a:pPr indent="-285750" lvl="0" marL="285750" marR="0" rtl="0" algn="l">
-              <a:lnSpc>
-                <a:spcPct val="100000"/>
-              </a:lnSpc>
-              <a:spcBef>
-                <a:spcPts val="0"/>
-              </a:spcBef>
-              <a:spcAft>
-                <a:spcPts val="0"/>
-              </a:spcAft>
-              <a:buClr>
-                <a:srgbClr val="000000"/>
-              </a:buClr>
-              <a:buSzPts val="1400"/>
-              <a:buFont typeface="Noto Sans Symbols"/>
-              <a:buChar char="■"/>
-            </a:pPr>
-            <a:r>
-              <a:rPr sz="1100" b="1">
-                <a:solidFill>
-                  <a:srgbClr val="0F172A"/>
-                </a:solidFill>
-                <a:latin typeface="Hiragino Sans"/>
-              </a:rPr>
-              <a:t>■ 個人情報やプライバシーへの配慮【必須】</a:t>
-            </a:r>
-            <a:endParaRPr/>
-          </a:p>
-          <a:p>
-            <a:r>
-              <a:rPr sz="950" b="0">
-                <a:solidFill>
-                  <a:srgbClr val="1E293B"/>
-                </a:solidFill>
-                <a:latin typeface="Hiragino Sans"/>
-              </a:rPr>
-              <a:t>個人情報保護法およびGDPRの理念に準拠し、カメラ映像や注文文に含まれる個人識別情報（PII：氏名・住所・電話・顔等）は、外部クラウドやブロックチェーンへ送る前にエッジ側で「正規表現ルール＋ローカルLLM境界補正」により即時マスク化する。また、保険査定や監査にはゼロ知識証明(ZKP)・完全準同型暗号(vFHE)を用い、生データを一切開示せずに検証を行う。</a:t>
-            </a:r>
-          </a:p>
-          <a:p>
-            <a:r>
-              <a:rPr sz="300" b="0">
-                <a:latin typeface="Hiragino Sans"/>
-              </a:rPr>
-              <a:t/>
-            </a:r>
-          </a:p>
-          <a:p>
-            <a:r>
-              <a:rPr sz="1100" b="1">
-                <a:solidFill>
-                  <a:srgbClr val="0F172A"/>
-                </a:solidFill>
-                <a:latin typeface="Hiragino Sans"/>
-              </a:rPr>
-              <a:t>■ 著作権・ライセンスの扱い【必須】</a:t>
-            </a:r>
-          </a:p>
-          <a:p>
-            <a:r>
-              <a:rPr sz="950" b="0">
-                <a:solidFill>
-                  <a:srgbClr val="1E293B"/>
-                </a:solidFill>
-                <a:latin typeface="Hiragino Sans"/>
-              </a:rPr>
-              <a:t>使用したオープンソースソフトウェア（Qwen3等のオープンウェイトモデル、OP-TEE、暗号ライブラリ等）はすべてApache-2.0 / MIT等のライセンス条件を遵守して利用しており、着想・引用した学術論文（CSS2026論文集、Merkle Japan資料等）はすべて出典と著者を明記している。また、参入企業の「AIモデルの革新的部分（重み・独自アルゴリズム）」の知的財産権(IP)を保護するため、モデル中身を秘匿したまま監査できる設計としている。</a:t>
-            </a:r>
-          </a:p>
-          <a:p>
-            <a:r>
-              <a:rPr sz="300" b="0">
-                <a:latin typeface="Hiragino Sans"/>
-              </a:rPr>
-              <a:t/>
-            </a:r>
-          </a:p>
-          <a:p>
-            <a:r>
-              <a:rPr sz="1100" b="1">
-                <a:solidFill>
-                  <a:srgbClr val="0F172A"/>
-                </a:solidFill>
-                <a:latin typeface="Hiragino Sans"/>
-              </a:rPr>
-              <a:t>■ データの扱い（安全性）【必須】</a:t>
-            </a:r>
-          </a:p>
-          <a:p>
-            <a:r>
-              <a:rPr sz="950" b="0">
-                <a:solidFill>
-                  <a:srgbClr val="1E293B"/>
-                </a:solidFill>
-                <a:latin typeface="Hiragino Sans"/>
-              </a:rPr>
-              <a:t>行動ログや商品Lookup検討証跡はMerkle Treeコミットメントと「指定確認者墨塗署名(DCSS：カメレオンハッシュ)」により改ざん不能かつ機密箇所を墨塗りした状態で保全する。さらに復号鍵は単独管理者の不正を防ぐため Shamir 3-of-5 秘密分散（AuditGuard）で5機関に分割し、3者の合意（Schnorrゼロ知識証明）がない限り復号できない。</a:t>
-            </a:r>
-          </a:p>
-          <a:p>
-            <a:r>
-              <a:rPr sz="300" b="0">
-                <a:latin typeface="Hiragino Sans"/>
-              </a:rPr>
-              <a:t/>
-            </a:r>
-          </a:p>
-          <a:p>
-            <a:r>
-              <a:rPr sz="1100" b="1">
-                <a:solidFill>
-                  <a:srgbClr val="0F172A"/>
-                </a:solidFill>
-                <a:latin typeface="Hiragino Sans"/>
-              </a:rPr>
-              <a:t>■ AI・センサー等を使う場合の倫理配慮【必須】</a:t>
-            </a:r>
-          </a:p>
-          <a:p>
-            <a:r>
-              <a:rPr sz="950" b="0">
-                <a:solidFill>
-                  <a:srgbClr val="1E293B"/>
-                </a:solidFill>
-                <a:latin typeface="Hiragino Sans"/>
-              </a:rPr>
-              <a:t>AIのハルシネーションや間接プロンプトインジェクション、センサの一時的な白飛び・死角による誤認識を前提とし、「AIの出力をそのまま物理モーターへ渡さない」設計を徹底した。具体的には、①決定論的Lintによる根拠位置(Locator)の強制、②VLAの未実行行動列との不一致度監視による即時実行長短縮、③モデル外の信頼ホスト(CNEI)による操作上限の物理強制を実装している。</a:t>
-            </a:r>
-          </a:p>
-          <a:p>
-            <a:r>
-              <a:rPr sz="300" b="0">
-                <a:latin typeface="Hiragino Sans"/>
-              </a:rPr>
-              <a:t/>
-            </a:r>
-          </a:p>
-          <a:p>
-            <a:r>
-              <a:rPr sz="1100" b="1">
-                <a:solidFill>
-                  <a:srgbClr val="0F172A"/>
-                </a:solidFill>
-                <a:latin typeface="Hiragino Sans"/>
-              </a:rPr>
-              <a:t>■ 利用者や社会にとって安心できる工夫【必須】</a:t>
-            </a:r>
-          </a:p>
-          <a:p>
-            <a:r>
-              <a:rPr sz="950" b="0">
-                <a:solidFill>
-                  <a:srgbClr val="1E293B"/>
-                </a:solidFill>
-                <a:latin typeface="Hiragino Sans"/>
-              </a:rPr>
-              <a:t>「なぜAIがその商品を選んだのか」「事故時に誰に責任があるのか」がブラックボックスにならないよう、お客様自身もスマホで検証でき、万が一のトラブル時には裁判所（指定確認者）が墨塗り前の真実を0.58msで検証できる透明性と説明責任（Accountability）を担保している。</a:t>
-            </a:r>
-          </a:p>
-        </p:txBody>
-      </p:sp>
-      <p:sp>
-        <p:nvSpPr>
-          <p:cNvPr id="157" name="Google Shape;157;p26"/>
-          <p:cNvSpPr txBox="1"/>
-          <p:nvPr>
-            <p:ph idx="12" type="sldNum"/>
-          </p:nvPr>
-        </p:nvSpPr>
-        <p:spPr>
-          <a:xfrm>
-            <a:off x="3974306" y="7194550"/>
-            <a:ext cx="2743200" cy="365125"/>
-          </a:xfrm>
-          <a:prstGeom prst="rect">
-            <a:avLst/>
-          </a:prstGeom>
-          <a:noFill/>
-          <a:ln>
-            <a:noFill/>
-          </a:ln>
-        </p:spPr>
-        <p:txBody>
-          <a:bodyPr anchorCtr="0" anchor="ctr" bIns="45700" lIns="91425" spcFirstLastPara="1" rIns="91425" wrap="square" tIns="45700">
-            <a:noAutofit/>
-          </a:bodyPr>
-          <a:lstStyle/>
-          <a:p>
-            <a:pPr indent="0" lvl="0" marL="0" rtl="0" algn="ctr">
-              <a:lnSpc>
-                <a:spcPct val="100000"/>
-              </a:lnSpc>
-              <a:spcBef>
-                <a:spcPts val="0"/>
-              </a:spcBef>
-              <a:spcAft>
-                <a:spcPts val="0"/>
-              </a:spcAft>
-              <a:buSzPts val="700"/>
-              <a:buNone/>
-            </a:pPr>
-            <a:fld id="{00000000-1234-1234-1234-123412341234}" type="slidenum">
-              <a:rPr lang="ja-JP"/>
-              <a:t>‹#›</a:t>
-            </a:fld>
-            <a:endParaRPr/>
-          </a:p>
-        </p:txBody>
-      </p:sp>
-    </p:spTree>
-  </p:cSld>
-  <p:clrMapOvr>
-    <a:masterClrMapping/>
-  </p:clrMapOvr>
-</p:sld>
-</file>
-
-<file path=ppt/slides/slide2.xml><?xml version="1.0" encoding="utf-8"?>
+<file path=ppt/slides/slide1.xml><?xml version="1.0" encoding="utf-8"?>
 <p:sld xmlns:a="http://schemas.openxmlformats.org/drawingml/2006/main" xmlns:r="http://schemas.openxmlformats.org/officeDocument/2006/relationships" xmlns:mc="http://schemas.openxmlformats.org/markup-compatibility/2006" xmlns:mv="urn:schemas-microsoft-com:mac:vml" xmlns:p="http://schemas.openxmlformats.org/presentationml/2006/main" xmlns:c="http://schemas.openxmlformats.org/drawingml/2006/chart" xmlns:dgm="http://schemas.openxmlformats.org/drawingml/2006/diagram" xmlns:o="urn:schemas-microsoft-com:office:office" xmlns:v="urn:schemas-microsoft-com:vml" xmlns:pvml="urn:schemas-microsoft-com:office:powerpoint" xmlns:com="http://schemas.openxmlformats.org/drawingml/2006/compatibility" xmlns:p14="http://schemas.microsoft.com/office/powerpoint/2010/main" xmlns:p15="http://schemas.microsoft.com/office/powerpoint/2012/main" xmlns:ahyp="http://schemas.microsoft.com/office/drawing/2018/hyperlinkcolor">
   <p:cSld>
     <p:spTree>
@@ -9280,13 +8350,13 @@
                         <a:buNone/>
                       </a:pPr>
                       <a:r>
-                        <a:rPr sz="1100" b="1">
+                        <a:rPr sz="1050" b="1">
                           <a:solidFill>
                             <a:srgbClr val="0F172A"/>
                           </a:solidFill>
                           <a:latin typeface="Hiragino Sans"/>
                         </a:rPr>
-                        <a:t>ProofPick（プルーフピック）：モデル知財とプライバシーを秘匿し「商品選択の根拠」と「安全性」を数学的に証明する物流・店舗ロボットオープン実行基盤</a:t>
+                        <a:t>ProofPick（プルーフピック）: モデル知財と顧客プライバシーを完全保護し、「商品選択の根拠」と「安全性」を数学的に証明する店舗・物流ロボット実行基盤</a:t>
                       </a:r>
                       <a:endParaRPr sz="1400" u="none" cap="none" strike="noStrike">
                         <a:solidFill>
@@ -9496,7 +8566,7 @@
                           </a:solidFill>
                           <a:latin typeface="Hiragino Sans"/>
                         </a:rPr>
-                        <a:t>Project ProofPick（分散AI・暗号監査ロボティクス探究班）</a:t>
+                        <a:t>Project ProofPick</a:t>
                       </a:r>
                       <a:endParaRPr sz="1400" u="none" cap="none" strike="noStrike">
                         <a:solidFill>
@@ -9666,7 +8736,7 @@
                           </a:solidFill>
                           <a:latin typeface="Hiragino Sans"/>
                         </a:rPr>
-                        <a:t>村上 大岳（※提出前に正式な代表者氏名・学年をご確認下さい）</a:t>
+                        <a:t>村上 大岳</a:t>
                       </a:r>
                       <a:endParaRPr sz="1400" u="none" cap="none" strike="noStrike">
                         <a:solidFill>
@@ -9856,7 +8926,7 @@
                           </a:solidFill>
                           <a:latin typeface="Hiragino Sans"/>
                         </a:rPr>
-                        <a:t>米川 明希 ほか（※提出前に正式なメンバー氏名をご確認下さい）</a:t>
+                        <a:t>米川 明希</a:t>
                       </a:r>
                       <a:endParaRPr sz="1400" u="none" cap="none" strike="noStrike">
                         <a:solidFill>
@@ -10043,7 +9113,598 @@
 </p:sld>
 </file>
 
-<file path=ppt/slides/slide3.xml><?xml version="1.0" encoding="utf-8"?>
+<file path=ppt/slides/slide10.xml><?xml version="1.0" encoding="utf-8"?>
+<p:sld xmlns:a="http://schemas.openxmlformats.org/drawingml/2006/main" xmlns:r="http://schemas.openxmlformats.org/officeDocument/2006/relationships" xmlns:mc="http://schemas.openxmlformats.org/markup-compatibility/2006" xmlns:mv="urn:schemas-microsoft-com:mac:vml" xmlns:p="http://schemas.openxmlformats.org/presentationml/2006/main" xmlns:c="http://schemas.openxmlformats.org/drawingml/2006/chart" xmlns:dgm="http://schemas.openxmlformats.org/drawingml/2006/diagram" xmlns:o="urn:schemas-microsoft-com:office:office" xmlns:v="urn:schemas-microsoft-com:vml" xmlns:pvml="urn:schemas-microsoft-com:office:powerpoint" xmlns:com="http://schemas.openxmlformats.org/drawingml/2006/compatibility" xmlns:p14="http://schemas.microsoft.com/office/powerpoint/2010/main" xmlns:p15="http://schemas.microsoft.com/office/powerpoint/2012/main" xmlns:ahyp="http://schemas.microsoft.com/office/drawing/2018/hyperlinkcolor">
+  <p:cSld>
+    <p:spTree>
+      <p:nvGrpSpPr>
+        <p:cNvPr id="145" name="Shape 145"/>
+        <p:cNvGrpSpPr/>
+        <p:nvPr/>
+      </p:nvGrpSpPr>
+      <p:grpSpPr>
+        <a:xfrm>
+          <a:off x="0" y="0"/>
+          <a:ext cx="0" cy="0"/>
+          <a:chOff x="0" y="0"/>
+          <a:chExt cx="0" cy="0"/>
+        </a:xfrm>
+      </p:grpSpPr>
+      <p:sp>
+        <p:nvSpPr>
+          <p:cNvPr id="146" name="Google Shape;146;p25"/>
+          <p:cNvSpPr txBox="1"/>
+          <p:nvPr/>
+        </p:nvSpPr>
+        <p:spPr>
+          <a:xfrm>
+            <a:off x="393700" y="276225"/>
+            <a:ext cx="7223252" cy="257758"/>
+          </a:xfrm>
+          <a:prstGeom prst="rect">
+            <a:avLst/>
+          </a:prstGeom>
+          <a:noFill/>
+          <a:ln>
+            <a:noFill/>
+          </a:ln>
+        </p:spPr>
+        <p:txBody>
+          <a:bodyPr anchorCtr="0" anchor="t" bIns="0" lIns="0" spcFirstLastPara="1" rIns="0" wrap="square" tIns="11425">
+            <a:spAutoFit/>
+          </a:bodyPr>
+          <a:lstStyle/>
+          <a:p>
+            <a:pPr indent="0" lvl="0" marL="12700" marR="0" rtl="0" algn="l">
+              <a:lnSpc>
+                <a:spcPct val="100000"/>
+              </a:lnSpc>
+              <a:spcBef>
+                <a:spcPts val="0"/>
+              </a:spcBef>
+              <a:spcAft>
+                <a:spcPts val="0"/>
+              </a:spcAft>
+              <a:buNone/>
+            </a:pPr>
+            <a:r>
+              <a:rPr b="1" i="0" lang="ja-JP" sz="1600" u="none" cap="none" strike="noStrike">
+                <a:solidFill>
+                  <a:schemeClr val="dk1"/>
+                </a:solidFill>
+                <a:latin typeface="Meiryo"/>
+                <a:ea typeface="Meiryo"/>
+                <a:cs typeface="Meiryo"/>
+                <a:sym typeface="Meiryo"/>
+              </a:rPr>
+              <a:t>作品詳細⑧（探究のプロセス）　</a:t>
+            </a:r>
+            <a:endParaRPr b="1" i="0" sz="1600" u="none" cap="none" strike="noStrike">
+              <a:solidFill>
+                <a:schemeClr val="dk1"/>
+              </a:solidFill>
+              <a:latin typeface="Meiryo"/>
+              <a:ea typeface="Meiryo"/>
+              <a:cs typeface="Meiryo"/>
+              <a:sym typeface="Meiryo"/>
+            </a:endParaRPr>
+          </a:p>
+        </p:txBody>
+      </p:sp>
+      <p:sp>
+        <p:nvSpPr>
+          <p:cNvPr id="148" name="Google Shape;148;p25"/>
+          <p:cNvSpPr txBox="1"/>
+          <p:nvPr/>
+        </p:nvSpPr>
+        <p:spPr>
+          <a:xfrm>
+            <a:off x="499443" y="1053169"/>
+            <a:ext cx="8778240" cy="5120640"/>
+          </a:xfrm>
+          <a:prstGeom prst="rect">
+            <a:avLst/>
+          </a:prstGeom>
+          <a:noFill/>
+          <a:ln>
+            <a:noFill/>
+          </a:ln>
+        </p:spPr>
+        <p:txBody>
+          <a:bodyPr anchorCtr="0" anchor="t" bIns="45700" lIns="91425" spcFirstLastPara="1" rIns="91425" wrap="square" tIns="45700">
+            <a:spAutoFit/>
+          </a:bodyPr>
+          <a:lstStyle/>
+          <a:p>
+            <a:pPr indent="-285750" lvl="0" marL="285750" marR="0" rtl="0" algn="l">
+              <a:lnSpc>
+                <a:spcPct val="100000"/>
+              </a:lnSpc>
+              <a:spcBef>
+                <a:spcPts val="0"/>
+              </a:spcBef>
+              <a:spcAft>
+                <a:spcPts val="0"/>
+              </a:spcAft>
+              <a:buClr>
+                <a:srgbClr val="000000"/>
+              </a:buClr>
+              <a:buSzPts val="1400"/>
+              <a:buFont typeface="Noto Sans Symbols"/>
+              <a:buChar char="■"/>
+            </a:pPr>
+            <a:r>
+              <a:rPr sz="1100" b="1">
+                <a:solidFill>
+                  <a:srgbClr val="0F172A"/>
+                </a:solidFill>
+                <a:latin typeface="Hiragino Sans"/>
+              </a:rPr>
+              <a:t>最初の「もやもや」はどんなものでしたか？【必須】</a:t>
+            </a:r>
+            <a:endParaRPr/>
+          </a:p>
+          <a:p>
+            <a:r>
+              <a:rPr sz="919" b="0">
+                <a:solidFill>
+                  <a:srgbClr val="1E293B"/>
+                </a:solidFill>
+                <a:latin typeface="Hiragino Sans"/>
+              </a:rPr>
+              <a:t>街で配膳ロボや清掃ロボを見かけるようになったが、「スーパーで買い物ロボットが棚のイタズラPOPに騙されて誤った商品を取ったらどうなるのか？」「子どもにぶつかった時、AIのバグなのか不可抗力なのか誰も証明できないし、カメラ映像が流出するのも怖い。これでは怖くて店に導入できないし保険にも入れないのでは？」と疑問に思ったことがきっかけ。</a:t>
+            </a:r>
+          </a:p>
+          <a:p>
+            <a:r>
+              <a:rPr sz="1100" b="1">
+                <a:solidFill>
+                  <a:srgbClr val="0F172A"/>
+                </a:solidFill>
+                <a:latin typeface="Hiragino Sans"/>
+              </a:rPr>
+              <a:t>調べたこと・試してみたことはなんですか？【必須】</a:t>
+            </a:r>
+          </a:p>
+          <a:p>
+            <a:r>
+              <a:rPr sz="900" b="0">
+                <a:solidFill>
+                  <a:srgbClr val="1E293B"/>
+                </a:solidFill>
+                <a:latin typeface="Hiragino Sans"/>
+              </a:rPr>
+              <a:t>1. 暗号プログラムでのグループ議論: AIエージェントの運用実績(task, trace)を機密非開示で損保に証明する保険モデルとvFHE(ZK+FHE)を設計
+2. 学会論文調査(CSS2026): プロンプトインジェクション防御(ASIDE+ICA)、Random Forest分岐器トリアージ、VLA動的チャンク制御、証跡Locatorの決定論的Lint、指定確認者墨塗署名(DCSS)の最新手法を分析
+3. プロトタイプ検証: 分岐器によるLLM呼出23%削減、OP-TEEでの自動署名670ms、DCSS墨塗り検証0.58msの実効性を確認</a:t>
+            </a:r>
+          </a:p>
+          <a:p>
+            <a:r>
+              <a:rPr sz="1100" b="1">
+                <a:solidFill>
+                  <a:srgbClr val="0F172A"/>
+                </a:solidFill>
+                <a:latin typeface="Hiragino Sans"/>
+              </a:rPr>
+              <a:t>得られた気づき（変化の瞬間）【必須】</a:t>
+            </a:r>
+          </a:p>
+          <a:p>
+            <a:r>
+              <a:rPr sz="919" b="0">
+                <a:solidFill>
+                  <a:srgbClr val="1E293B"/>
+                </a:solidFill>
+                <a:latin typeface="Hiragino Sans"/>
+              </a:rPr>
+              <a:t>「全部を大型LLMとフルZK証明で動かす」のはコスト・遅延的に無理があると判明した
+スーパー側が自前で何台もロボットを購入・維持管理すること自体が不可能であり、一方で参入するAI企業も「モデルの革新的な重み(知財)」を監査のために開示したくないという強いジレンマに気づいた</a:t>
+            </a:r>
+          </a:p>
+          <a:p>
+            <a:r>
+              <a:rPr sz="1100" b="1">
+                <a:solidFill>
+                  <a:srgbClr val="0F172A"/>
+                </a:solidFill>
+                <a:latin typeface="Hiragino Sans"/>
+              </a:rPr>
+              <a:t>問いがどう変わったか【必須】</a:t>
+            </a:r>
+          </a:p>
+          <a:p>
+            <a:r>
+              <a:rPr sz="919" b="0">
+                <a:solidFill>
+                  <a:srgbClr val="1E293B"/>
+                </a:solidFill>
+                <a:latin typeface="Hiragino Sans"/>
+              </a:rPr>
+              <a:t>最初の問い: 「どうやって賢い買い物ロボットを作るか？」
+今の問い: 「店舗は『場とZK検証基盤』だけを提供し、外部のロボットが『モデル知財とプライバシーを隠したまま、Lookup検討と安全性を数学的に証明』して報酬を得るインフラをどう構築するか？」</a:t>
+            </a:r>
+          </a:p>
+          <a:p>
+            <a:r>
+              <a:rPr sz="1100" b="1">
+                <a:solidFill>
+                  <a:srgbClr val="0F172A"/>
+                </a:solidFill>
+                <a:latin typeface="Hiragino Sans"/>
+              </a:rPr>
+              <a:t>次にやってみたいこと【必須】</a:t>
+            </a:r>
+          </a:p>
+          <a:p>
+            <a:r>
+              <a:rPr sz="900" b="0">
+                <a:solidFill>
+                  <a:srgbClr val="1E293B"/>
+                </a:solidFill>
+                <a:latin typeface="Hiragino Sans"/>
+              </a:rPr>
+              <a:t>1. 実店舗・実倉庫での走行実験: 実際のスーパー棚と物流テストコースで複数ロボットを走らせ、ピッキング速度と安全性を評価
+2. 損保会社との共同実証: 実際の保険約款を取り込み、ZK証明を用いた自動保険料割引と事故時即時支払いのパイロット運用
+3. 異種ロボット間P2Pリソース融通: 通路混雑情報や充電枠をロボット同士で自律的に売買・融通する経済圏の実装</a:t>
+            </a:r>
+          </a:p>
+        </p:txBody>
+      </p:sp>
+      <p:sp>
+        <p:nvSpPr>
+          <p:cNvPr id="149" name="Google Shape;149;p25"/>
+          <p:cNvSpPr txBox="1"/>
+          <p:nvPr>
+            <p:ph idx="12" type="sldNum"/>
+          </p:nvPr>
+        </p:nvSpPr>
+        <p:spPr>
+          <a:xfrm>
+            <a:off x="3974306" y="7194550"/>
+            <a:ext cx="2743200" cy="365125"/>
+          </a:xfrm>
+          <a:prstGeom prst="rect">
+            <a:avLst/>
+          </a:prstGeom>
+          <a:noFill/>
+          <a:ln>
+            <a:noFill/>
+          </a:ln>
+        </p:spPr>
+        <p:txBody>
+          <a:bodyPr anchorCtr="0" anchor="ctr" bIns="45700" lIns="91425" spcFirstLastPara="1" rIns="91425" wrap="square" tIns="45700">
+            <a:noAutofit/>
+          </a:bodyPr>
+          <a:lstStyle/>
+          <a:p>
+            <a:pPr indent="0" lvl="0" marL="0" rtl="0" algn="ctr">
+              <a:lnSpc>
+                <a:spcPct val="100000"/>
+              </a:lnSpc>
+              <a:spcBef>
+                <a:spcPts val="0"/>
+              </a:spcBef>
+              <a:spcAft>
+                <a:spcPts val="0"/>
+              </a:spcAft>
+              <a:buSzPts val="700"/>
+              <a:buNone/>
+            </a:pPr>
+            <a:fld id="{00000000-1234-1234-1234-123412341234}" type="slidenum">
+              <a:rPr lang="ja-JP"/>
+              <a:t>‹#›</a:t>
+            </a:fld>
+            <a:endParaRPr/>
+          </a:p>
+        </p:txBody>
+      </p:sp>
+    </p:spTree>
+  </p:cSld>
+  <p:clrMapOvr>
+    <a:masterClrMapping/>
+  </p:clrMapOvr>
+</p:sld>
+</file>
+
+<file path=ppt/slides/slide11.xml><?xml version="1.0" encoding="utf-8"?>
+<p:sld xmlns:a="http://schemas.openxmlformats.org/drawingml/2006/main" xmlns:r="http://schemas.openxmlformats.org/officeDocument/2006/relationships" xmlns:mc="http://schemas.openxmlformats.org/markup-compatibility/2006" xmlns:mv="urn:schemas-microsoft-com:mac:vml" xmlns:p="http://schemas.openxmlformats.org/presentationml/2006/main" xmlns:c="http://schemas.openxmlformats.org/drawingml/2006/chart" xmlns:dgm="http://schemas.openxmlformats.org/drawingml/2006/diagram" xmlns:o="urn:schemas-microsoft-com:office:office" xmlns:v="urn:schemas-microsoft-com:vml" xmlns:pvml="urn:schemas-microsoft-com:office:powerpoint" xmlns:com="http://schemas.openxmlformats.org/drawingml/2006/compatibility" xmlns:p14="http://schemas.microsoft.com/office/powerpoint/2010/main" xmlns:p15="http://schemas.microsoft.com/office/powerpoint/2012/main" xmlns:ahyp="http://schemas.microsoft.com/office/drawing/2018/hyperlinkcolor">
+  <p:cSld>
+    <p:spTree>
+      <p:nvGrpSpPr>
+        <p:cNvPr id="153" name="Shape 153"/>
+        <p:cNvGrpSpPr/>
+        <p:nvPr/>
+      </p:nvGrpSpPr>
+      <p:grpSpPr>
+        <a:xfrm>
+          <a:off x="0" y="0"/>
+          <a:ext cx="0" cy="0"/>
+          <a:chOff x="0" y="0"/>
+          <a:chExt cx="0" cy="0"/>
+        </a:xfrm>
+      </p:grpSpPr>
+      <p:sp>
+        <p:nvSpPr>
+          <p:cNvPr id="154" name="Google Shape;154;p26"/>
+          <p:cNvSpPr txBox="1"/>
+          <p:nvPr/>
+        </p:nvSpPr>
+        <p:spPr>
+          <a:xfrm>
+            <a:off x="393700" y="276225"/>
+            <a:ext cx="7223252" cy="257758"/>
+          </a:xfrm>
+          <a:prstGeom prst="rect">
+            <a:avLst/>
+          </a:prstGeom>
+          <a:noFill/>
+          <a:ln>
+            <a:noFill/>
+          </a:ln>
+        </p:spPr>
+        <p:txBody>
+          <a:bodyPr anchorCtr="0" anchor="t" bIns="0" lIns="0" spcFirstLastPara="1" rIns="0" wrap="square" tIns="11425">
+            <a:spAutoFit/>
+          </a:bodyPr>
+          <a:lstStyle/>
+          <a:p>
+            <a:pPr indent="0" lvl="0" marL="12700" marR="0" rtl="0" algn="l">
+              <a:lnSpc>
+                <a:spcPct val="100000"/>
+              </a:lnSpc>
+              <a:spcBef>
+                <a:spcPts val="0"/>
+              </a:spcBef>
+              <a:spcAft>
+                <a:spcPts val="0"/>
+              </a:spcAft>
+              <a:buNone/>
+            </a:pPr>
+            <a:r>
+              <a:rPr b="1" i="0" lang="ja-JP" sz="1600" u="none" cap="none" strike="noStrike">
+                <a:solidFill>
+                  <a:schemeClr val="dk1"/>
+                </a:solidFill>
+                <a:latin typeface="Meiryo"/>
+                <a:ea typeface="Meiryo"/>
+                <a:cs typeface="Meiryo"/>
+                <a:sym typeface="Meiryo"/>
+              </a:rPr>
+              <a:t>作品詳細⑨（倫理・法的遵守）　</a:t>
+            </a:r>
+            <a:endParaRPr b="1" i="0" sz="1600" u="none" cap="none" strike="noStrike">
+              <a:solidFill>
+                <a:schemeClr val="dk1"/>
+              </a:solidFill>
+              <a:latin typeface="Meiryo"/>
+              <a:ea typeface="Meiryo"/>
+              <a:cs typeface="Meiryo"/>
+              <a:sym typeface="Meiryo"/>
+            </a:endParaRPr>
+          </a:p>
+        </p:txBody>
+      </p:sp>
+      <p:sp>
+        <p:nvSpPr>
+          <p:cNvPr id="156" name="Google Shape;156;p26"/>
+          <p:cNvSpPr txBox="1"/>
+          <p:nvPr/>
+        </p:nvSpPr>
+        <p:spPr>
+          <a:xfrm>
+            <a:off x="452549" y="1186610"/>
+            <a:ext cx="8778240" cy="5120640"/>
+          </a:xfrm>
+          <a:prstGeom prst="rect">
+            <a:avLst/>
+          </a:prstGeom>
+          <a:noFill/>
+          <a:ln>
+            <a:noFill/>
+          </a:ln>
+        </p:spPr>
+        <p:txBody>
+          <a:bodyPr anchorCtr="0" anchor="t" bIns="45700" lIns="91425" spcFirstLastPara="1" rIns="91425" wrap="square" tIns="45700">
+            <a:spAutoFit/>
+          </a:bodyPr>
+          <a:lstStyle/>
+          <a:p>
+            <a:pPr indent="-285750" lvl="0" marL="285750" marR="0" rtl="0" algn="l">
+              <a:lnSpc>
+                <a:spcPct val="100000"/>
+              </a:lnSpc>
+              <a:spcBef>
+                <a:spcPts val="0"/>
+              </a:spcBef>
+              <a:spcAft>
+                <a:spcPts val="0"/>
+              </a:spcAft>
+              <a:buClr>
+                <a:srgbClr val="000000"/>
+              </a:buClr>
+              <a:buSzPts val="1400"/>
+              <a:buFont typeface="Noto Sans Symbols"/>
+              <a:buChar char="■"/>
+            </a:pPr>
+            <a:r>
+              <a:rPr sz="1100" b="1">
+                <a:solidFill>
+                  <a:srgbClr val="0F172A"/>
+                </a:solidFill>
+                <a:latin typeface="Hiragino Sans"/>
+              </a:rPr>
+              <a:t>個人情報やプライバシーへの配慮【必須】</a:t>
+            </a:r>
+            <a:endParaRPr/>
+          </a:p>
+          <a:p>
+            <a:r>
+              <a:rPr sz="919" b="0">
+                <a:solidFill>
+                  <a:srgbClr val="1E293B"/>
+                </a:solidFill>
+                <a:latin typeface="Hiragino Sans"/>
+              </a:rPr>
+              <a:t>完全エッジマスク: カメラ映像の顧客顔画像や注文文の個人情報は、外部へ送信する前にエッジで即時マスク化
+生データの非開示: 保険査定や第三者監査にはゼロ知識証明(ZKP)と完全準同型暗号(vFHE)を用い、生の購買履歴や個人情報を一切渡さない
+匿名化: ブロックチェーン上の記録には顧客実名を含めず、一時的なセッションIDのみを使用</a:t>
+            </a:r>
+          </a:p>
+          <a:p>
+            <a:r>
+              <a:rPr sz="1100" b="1">
+                <a:solidFill>
+                  <a:srgbClr val="0F172A"/>
+                </a:solidFill>
+                <a:latin typeface="Hiragino Sans"/>
+              </a:rPr>
+              <a:t>著作権・ライセンスの扱い【必須】</a:t>
+            </a:r>
+          </a:p>
+          <a:p>
+            <a:r>
+              <a:rPr sz="919" b="0">
+                <a:solidFill>
+                  <a:srgbClr val="1E293B"/>
+                </a:solidFill>
+                <a:latin typeface="Hiragino Sans"/>
+              </a:rPr>
+              <a:t>オープンソースライセンス準拠: 使用したOSS（Qwen3, OP-TEE, 暗号ライブラリ等）はApache 2.0 / MITに準拠
+学術出典の明記: CSS2026論文集など参照した研究成果はすべて出典と権利者を明示
+モデル知財(IP)の保護: 参入企業の独自重みやアルゴリズムを開示させずに安全性を証明できる仕組みにより、企業の知的財産権を完全に保護</a:t>
+            </a:r>
+          </a:p>
+          <a:p>
+            <a:r>
+              <a:rPr sz="1100" b="1">
+                <a:solidFill>
+                  <a:srgbClr val="0F172A"/>
+                </a:solidFill>
+                <a:latin typeface="Hiragino Sans"/>
+              </a:rPr>
+              <a:t>データの扱い（安全性）【必須】</a:t>
+            </a:r>
+          </a:p>
+          <a:p>
+            <a:r>
+              <a:rPr sz="919" b="0">
+                <a:solidFill>
+                  <a:srgbClr val="1E293B"/>
+                </a:solidFill>
+                <a:latin typeface="Hiragino Sans"/>
+              </a:rPr>
+              <a:t>改ざん防止: 商品検討ログはMerkle Treeと指定確認者墨塗署名(DCSS)で暗号学的に保全
+秘密分散による鍵管理: 監査復号鍵はShamir 3-of-5秘密分散（AuditGuard）で5機関に分割保持し、単独での不正開示を防止
+アクセス制限: 物理ロボットの実行権限はOP-TEEセキュアストレージ内に隔離</a:t>
+            </a:r>
+          </a:p>
+          <a:p>
+            <a:r>
+              <a:rPr sz="1100" b="1">
+                <a:solidFill>
+                  <a:srgbClr val="0F172A"/>
+                </a:solidFill>
+                <a:latin typeface="Hiragino Sans"/>
+              </a:rPr>
+              <a:t>AI・センサー等を使う場合の倫理配慮【必須】</a:t>
+            </a:r>
+          </a:p>
+          <a:p>
+            <a:r>
+              <a:rPr sz="919" b="0">
+                <a:solidFill>
+                  <a:srgbClr val="1E293B"/>
+                </a:solidFill>
+                <a:latin typeface="Hiragino Sans"/>
+              </a:rPr>
+              <a:t>AIへの丸投げ禁止: 決定論的Lintによる根拠位置(Locator)強制、VLA不一致度監視による減速停止、モデル外CNEIによる物理上限強制
+バイアス・誤認識対策: 特定商品への偏った誘導がないかをZK Lookupで検証可能にし、センサー死角時は安全側に倒れる設計</a:t>
+            </a:r>
+          </a:p>
+          <a:p>
+            <a:r>
+              <a:rPr sz="1100" b="1">
+                <a:solidFill>
+                  <a:srgbClr val="0F172A"/>
+                </a:solidFill>
+                <a:latin typeface="Hiragino Sans"/>
+              </a:rPr>
+              <a:t>利用者や社会にとって安心できる工夫【必須】</a:t>
+            </a:r>
+          </a:p>
+          <a:p>
+            <a:r>
+              <a:rPr sz="919" b="0">
+                <a:solidFill>
+                  <a:srgbClr val="1E293B"/>
+                </a:solidFill>
+                <a:latin typeface="Hiragino Sans"/>
+              </a:rPr>
+              <a:t>説明責任の担保: 「なぜその商品を選んだか」をお客様自身がスマホで検証でき、ブラックボックス化を排除
+心理的負担の排除: 常時監視されている感覚を与えないプライバシー設計
+社会的価値: 店舗や物流の人手不足を解消しつつ、アレルギー事故や衝突事故のリスクを数学的に防ぐ</a:t>
+            </a:r>
+          </a:p>
+        </p:txBody>
+      </p:sp>
+      <p:sp>
+        <p:nvSpPr>
+          <p:cNvPr id="157" name="Google Shape;157;p26"/>
+          <p:cNvSpPr txBox="1"/>
+          <p:nvPr>
+            <p:ph idx="12" type="sldNum"/>
+          </p:nvPr>
+        </p:nvSpPr>
+        <p:spPr>
+          <a:xfrm>
+            <a:off x="3974306" y="7194550"/>
+            <a:ext cx="2743200" cy="365125"/>
+          </a:xfrm>
+          <a:prstGeom prst="rect">
+            <a:avLst/>
+          </a:prstGeom>
+          <a:noFill/>
+          <a:ln>
+            <a:noFill/>
+          </a:ln>
+        </p:spPr>
+        <p:txBody>
+          <a:bodyPr anchorCtr="0" anchor="ctr" bIns="45700" lIns="91425" spcFirstLastPara="1" rIns="91425" wrap="square" tIns="45700">
+            <a:noAutofit/>
+          </a:bodyPr>
+          <a:lstStyle/>
+          <a:p>
+            <a:pPr indent="0" lvl="0" marL="0" rtl="0" algn="ctr">
+              <a:lnSpc>
+                <a:spcPct val="100000"/>
+              </a:lnSpc>
+              <a:spcBef>
+                <a:spcPts val="0"/>
+              </a:spcBef>
+              <a:spcAft>
+                <a:spcPts val="0"/>
+              </a:spcAft>
+              <a:buSzPts val="700"/>
+              <a:buNone/>
+            </a:pPr>
+            <a:fld id="{00000000-1234-1234-1234-123412341234}" type="slidenum">
+              <a:rPr lang="ja-JP"/>
+              <a:t>‹#›</a:t>
+            </a:fld>
+            <a:endParaRPr/>
+          </a:p>
+        </p:txBody>
+      </p:sp>
+    </p:spTree>
+  </p:cSld>
+  <p:clrMapOvr>
+    <a:masterClrMapping/>
+  </p:clrMapOvr>
+</p:sld>
+</file>
+
+<file path=ppt/slides/slide2.xml><?xml version="1.0" encoding="utf-8"?>
 <p:sld xmlns:a="http://schemas.openxmlformats.org/drawingml/2006/main" xmlns:r="http://schemas.openxmlformats.org/officeDocument/2006/relationships" xmlns:mc="http://schemas.openxmlformats.org/markup-compatibility/2006" xmlns:mv="urn:schemas-microsoft-com:mac:vml" xmlns:p="http://schemas.openxmlformats.org/presentationml/2006/main" xmlns:c="http://schemas.openxmlformats.org/drawingml/2006/chart" xmlns:dgm="http://schemas.openxmlformats.org/drawingml/2006/diagram" xmlns:o="urn:schemas-microsoft-com:office:office" xmlns:v="urn:schemas-microsoft-com:vml" xmlns:pvml="urn:schemas-microsoft-com:office:powerpoint" xmlns:com="http://schemas.openxmlformats.org/drawingml/2006/compatibility" xmlns:p14="http://schemas.microsoft.com/office/powerpoint/2010/main" xmlns:p15="http://schemas.microsoft.com/office/powerpoint/2012/main" xmlns:ahyp="http://schemas.microsoft.com/office/drawing/2018/hyperlinkcolor">
   <p:cSld>
     <p:spTree>
@@ -10356,13 +10017,13 @@
               <a:buNone/>
             </a:pPr>
             <a:r>
-              <a:rPr sz="1200" b="1">
+              <a:rPr sz="1150" b="1">
                 <a:solidFill>
                   <a:srgbClr val="10B981"/>
                 </a:solidFill>
                 <a:latin typeface="Hiragino Sans"/>
               </a:rPr>
-              <a:t>AIの企業秘密と個人情報を隠したまま、商品選択の正しさと安全を数学的に証明するロボット実行基盤（48文字）</a:t>
+              <a:t>AIの企業秘密を守り、商品選択の理由と安全性を数学的に証明するロボット基盤（38文字）</a:t>
             </a:r>
             <a:endParaRPr b="0" i="0" sz="1200" u="none" cap="none" strike="noStrike">
               <a:solidFill>
@@ -10574,7 +10235,7 @@
                 </a:solidFill>
                 <a:latin typeface="Hiragino Sans"/>
               </a:rPr>
-              <a:t>スーパーや物流倉庫は自前でロボットを維持管理できず、外部AIロボを入れるにも「悪意あるPOPによる誤動作」「個人情報漏洩」「事故時の責任不明」が壁となり導入が進まない課題を解決する。</a:t>
+              <a:t>スーパーや物流倉庫がロボットを維持管理できず、外部AIロボ導入も「POP騙され誤動作」「個人情報漏洩」「事故時の責任不明」が壁となり普及しない課題を解決したい。</a:t>
             </a:r>
             <a:endParaRPr/>
           </a:p>
@@ -10772,13 +10433,16 @@
               <a:buChar char="•"/>
             </a:pPr>
             <a:r>
-              <a:rPr sz="950" b="0">
+              <a:rPr sz="900" b="0">
                 <a:solidFill>
                   <a:srgbClr val="1E293B"/>
                 </a:solidFill>
                 <a:latin typeface="Hiragino Sans"/>
               </a:rPr>
-              <a:t>①人手不足のスーパー・物流倉庫事業者、②独自モデルの知財を守りつつ参入したいAI・ロボット開発企業、③買い物代行を利用する来店客（アレルギー保持者・高齢者等）、④損保会社</a:t>
+              <a:t>人手不足のスーパー・物流倉庫の現場責任者
+買い物代行を利用する顧客（特にアレルギー児の保護者や高齢者）
+自社モデルの知財を守りつつ参入したいAI・ロボット開発企業
+安全性を確認して保険を提供したい損保会社</a:t>
             </a:r>
             <a:endParaRPr b="0" i="0" sz="1200" u="none" cap="none" strike="noStrike">
               <a:solidFill>
@@ -10984,13 +10648,18 @@
               <a:buChar char="•"/>
             </a:pPr>
             <a:r>
-              <a:rPr sz="1000" b="1">
-                <a:solidFill>
-                  <a:srgbClr val="0F172A"/>
+              <a:rPr sz="880" b="0">
+                <a:solidFill>
+                  <a:srgbClr val="1E293B"/>
                 </a:solidFill>
                 <a:latin typeface="Hiragino Sans"/>
               </a:rPr>
-              <a:t>【オープン実行基盤 ＋ 標準モデル ＋ ピックアップ検証モック】</a:t>
+              <a:t>1. 注文受付・マスク: 注文や画像から個人情報をエッジで即時マスク化
+2. 分岐器トリアージ: 定型注文はLLMを介さず高速処理（呼出23%削減）
+3. 防御推論: ASIDE+ICAで店内偽POPを遮断、動的チャンク制御で暴走抑制
+4. Lookup検討証明: どの正規商品テーブルと比較検討したかをZKで証明
+5. モデル外安全強制: TEE内のCNEIゲートで要求超過操作を100%遮断
+6. 経済・保険監査: ZK無開示査定と有事の指定確認者墨塗署名(DCSS)で監査</a:t>
             </a:r>
             <a:endParaRPr b="0" i="0" sz="1200" u="none" cap="none" strike="noStrike">
               <a:solidFill>
@@ -11001,50 +10670,6 @@
               <a:cs typeface="Meiryo"/>
               <a:sym typeface="Meiryo"/>
             </a:endParaRPr>
-          </a:p>
-          <a:p>
-            <a:r>
-              <a:rPr sz="950" b="0">
-                <a:solidFill>
-                  <a:srgbClr val="1E293B"/>
-                </a:solidFill>
-                <a:latin typeface="Hiragino Sans"/>
-              </a:rPr>
-              <a:t>①前段の分岐器(RF/LR Router)とPIIマスクで定型注文を高速処理(LLM呼出23%削減)・個人情報を保護。</a:t>
-            </a:r>
-          </a:p>
-          <a:p>
-            <a:r>
-              <a:rPr sz="950" b="0">
-                <a:solidFill>
-                  <a:srgbClr val="1E293B"/>
-                </a:solidFill>
-                <a:latin typeface="Hiragino Sans"/>
-              </a:rPr>
-              <a:t>②分散LLMの動的ゲート(ASIDE+ICA)とVLA動的チャンク制御で、店内の偽POPによるインジェクションや照明白飛びによる暴走を遮断。</a:t>
-            </a:r>
-          </a:p>
-          <a:p>
-            <a:r>
-              <a:rPr sz="950" b="0">
-                <a:solidFill>
-                  <a:srgbClr val="1E293B"/>
-                </a:solidFill>
-                <a:latin typeface="Hiragino Sans"/>
-              </a:rPr>
-              <a:t>③「どの商品群をルックアップ比較して選んだか」をゼロ知識証明(ZK Lookup)・完全準同型暗号(vFHE)で数学的に証明。</a:t>
-            </a:r>
-          </a:p>
-          <a:p>
-            <a:r>
-              <a:rPr sz="950" b="0">
-                <a:solidFill>
-                  <a:srgbClr val="1E293B"/>
-                </a:solidFill>
-                <a:latin typeface="Hiragino Sans"/>
-              </a:rPr>
-              <a:t>④店舗は「場と検証基盤」のみ提供し、外部ロボが稼働してブロックチェーンで報酬を得る資本効率モデルと、ZK＋指定確認者墨塗署名(DCSS)によるAI保険を実現。</a:t>
-            </a:r>
           </a:p>
         </p:txBody>
       </p:sp>
@@ -11389,26 +11014,17 @@
               <a:buChar char="•"/>
             </a:pPr>
             <a:r>
-              <a:rPr sz="900" b="0">
+              <a:rPr sz="850" b="0">
                 <a:solidFill>
                   <a:srgbClr val="1E293B"/>
                 </a:solidFill>
                 <a:latin typeface="Hiragino Sans"/>
               </a:rPr>
-              <a:t>①AIに丸投げせず「分岐器トリアージ＋モデル外安全強制(CNEI)」で要求超過を100%遮断した点。</a:t>
+              <a:t>モデル知財の完全秘匿: 企業の独自重みやアルゴリズムを一切明かさず安全稼働だけを証明
+AI任せにしない二重防御: 分岐器トリアージとモデル外TEE強制で要求超過をゼロ化
+一般人でもわかるトラスト: 難しい数式ではなくスマホで「安心の緑バッジ」を確認可能</a:t>
             </a:r>
             <a:endParaRPr/>
-          </a:p>
-          <a:p>
-            <a:r>
-              <a:rPr sz="900" b="0">
-                <a:solidFill>
-                  <a:srgbClr val="1E293B"/>
-                </a:solidFill>
-                <a:latin typeface="Hiragino Sans"/>
-              </a:rPr>
-              <a:t>②AI企業の「モデルの革新的部分(重み・知財)」と「顧客データ」を一切明かさず、商品Lookup検討の正しさだけを数学的(ZK/vFHE)に証明し、お客様・店舗・損保が直接検証できる点。</a:t>
-            </a:r>
           </a:p>
         </p:txBody>
       </p:sp>
@@ -11604,13 +11220,14 @@
               <a:buChar char="•"/>
             </a:pPr>
             <a:r>
-              <a:rPr sz="900" b="0">
+              <a:rPr sz="850" b="0">
                 <a:solidFill>
                   <a:srgbClr val="1E293B"/>
                 </a:solidFill>
                 <a:latin typeface="Hiragino Sans"/>
               </a:rPr>
-              <a:t>昼はスーパーの買い物ピックアップ、夜は物流倉庫の仕分け最適化として外部ロボが24時間稼働し、タスク完遂ごとにインセンティブが還流する高資本効率な社会インフラを実現。</a:t>
+              <a:t>昼はスーパーの買い物代行、夜は物流倉庫の仕分け最適化として外部ロボが24時間稼働
+ロボット所有コスト不要で人手不足を解消し、タスク完遂ごとに即座に報酬が還元される</a:t>
             </a:r>
             <a:endParaRPr/>
           </a:p>
@@ -11659,13 +11276,18 @@
               <a:buChar char="•"/>
             </a:pPr>
             <a:r>
-              <a:rPr sz="900" b="1">
-                <a:solidFill>
-                  <a:srgbClr val="0F172A"/>
+              <a:rPr sz="819" b="0">
+                <a:solidFill>
+                  <a:srgbClr val="1E293B"/>
                 </a:solidFill>
                 <a:latin typeface="Hiragino Sans"/>
               </a:rPr>
-              <a:t>【使用した技術（選択肢より）】</a:t>
+              <a:t>プログラムやアプリを作った（FastAPI, Python, C++, OP-TEE）
+センサーやデバイスをプログラムで動かした（Arduino, 深度カメラ）
+データを分析・可視化した（ZK Lookup Proof, 比較検討トレース）
+カメラの映像・画像をAIで判定した（YOLOv8, VLAモデル）
+LLMエージェント・自動化AIを使った（Qwen3, ASIDE+ICA）
+その他（ゼロ知識証明ZKP, 完全準同型暗号vFHE, ブロックチェーン）</a:t>
             </a:r>
             <a:endParaRPr b="0" i="0" sz="1200" u="none" cap="none" strike="noStrike">
               <a:solidFill>
@@ -11676,39 +11298,6 @@
               <a:cs typeface="Meiryo"/>
               <a:sym typeface="Meiryo"/>
             </a:endParaRPr>
-          </a:p>
-          <a:p>
-            <a:r>
-              <a:rPr sz="850" b="0">
-                <a:solidFill>
-                  <a:srgbClr val="1E293B"/>
-                </a:solidFill>
-                <a:latin typeface="Hiragino Sans"/>
-              </a:rPr>
-              <a:t>・プログラムやアプリを作った／ロボットを動かした／センサーで情報を集めた／LLMエージェント・自動化AIを使った／強化学習や高度なAI手法を使った／その他（ゼロ知識証明ZKP・完全準同型暗号vFHE・TEE・ブロックチェーン）</a:t>
-            </a:r>
-          </a:p>
-          <a:p>
-            <a:r>
-              <a:rPr sz="900" b="1">
-                <a:solidFill>
-                  <a:srgbClr val="0F172A"/>
-                </a:solidFill>
-                <a:latin typeface="Hiragino Sans"/>
-              </a:rPr>
-              <a:t>【AIの利用用途（選択肢より）】</a:t>
-            </a:r>
-          </a:p>
-          <a:p>
-            <a:r>
-              <a:rPr sz="850" b="0">
-                <a:solidFill>
-                  <a:srgbClr val="1E293B"/>
-                </a:solidFill>
-                <a:latin typeface="Hiragino Sans"/>
-              </a:rPr>
-              <a:t>・カメラの映像・画像をAIで判定した／マイクやセンサーのデータをAIで分析した／自分たちでAIを学習させた（分岐器トリアージ・動的アダプタ制御）／プログラムをAIに手伝ってもらった</a:t>
-            </a:r>
           </a:p>
         </p:txBody>
       </p:sp>
@@ -11720,7 +11309,7 @@
 </p:sld>
 </file>
 
-<file path=ppt/slides/slide4.xml><?xml version="1.0" encoding="utf-8"?>
+<file path=ppt/slides/slide3.xml><?xml version="1.0" encoding="utf-8"?>
 <p:sld xmlns:a="http://schemas.openxmlformats.org/drawingml/2006/main" xmlns:r="http://schemas.openxmlformats.org/officeDocument/2006/relationships" xmlns:mc="http://schemas.openxmlformats.org/markup-compatibility/2006" xmlns:mv="urn:schemas-microsoft-com:mac:vml" xmlns:p="http://schemas.openxmlformats.org/presentationml/2006/main" xmlns:c="http://schemas.openxmlformats.org/drawingml/2006/chart" xmlns:dgm="http://schemas.openxmlformats.org/drawingml/2006/diagram" xmlns:o="urn:schemas-microsoft-com:office:office" xmlns:v="urn:schemas-microsoft-com:vml" xmlns:pvml="urn:schemas-microsoft-com:office:powerpoint" xmlns:com="http://schemas.openxmlformats.org/drawingml/2006/compatibility" xmlns:p14="http://schemas.microsoft.com/office/powerpoint/2010/main" xmlns:p15="http://schemas.microsoft.com/office/powerpoint/2012/main" xmlns:ahyp="http://schemas.microsoft.com/office/drawing/2018/hyperlinkcolor">
   <p:cSld>
     <p:spTree>
@@ -11841,13 +11430,13 @@
               <a:buChar char="■"/>
             </a:pPr>
             <a:r>
-              <a:rPr sz="1200" b="1">
+              <a:rPr sz="1100" b="1">
                 <a:solidFill>
                   <a:srgbClr val="0F172A"/>
                 </a:solidFill>
                 <a:latin typeface="Hiragino Sans"/>
               </a:rPr>
-              <a:t>■ 取り組む課題【必須】</a:t>
+              <a:t>取り組む課題【必須】</a:t>
             </a:r>
             <a:endParaRPr b="1" i="0" sz="1400" u="none" cap="none" strike="noStrike">
               <a:solidFill>
@@ -11861,114 +11450,88 @@
           </a:p>
           <a:p>
             <a:r>
-              <a:rPr sz="1050" b="0">
+              <a:rPr sz="950" b="0">
                 <a:solidFill>
                   <a:srgbClr val="1E293B"/>
                 </a:solidFill>
                 <a:latin typeface="Hiragino Sans"/>
               </a:rPr>
-              <a:t>スーパーや物流センターにおける「自律ピッキングロボット導入の壁（①高額な維持管理コスト、②悪意あるPOP等によるAI誤動作・安全性への不安、③AI企業のモデル知財保護と第三者監査・保険査定のジレンマ）」を解決する。</a:t>
+              <a:t>スーパーや物流倉庫における「自律ピッキングロボット導入の3つの壁（高額な機体維持管理コスト、悪意あるPOPやノイズによるAI誤動作の不安、モデルの企業秘密保護と事故時保険監査のジレンマ）」を解決する。</a:t>
             </a:r>
           </a:p>
           <a:p>
             <a:r>
-              <a:rPr sz="600" b="0">
+              <a:rPr sz="1100" b="1">
+                <a:solidFill>
+                  <a:srgbClr val="0F172A"/>
+                </a:solidFill>
                 <a:latin typeface="Hiragino Sans"/>
               </a:rPr>
-              <a:t/>
+              <a:t>課題の背景・現状【必須】</a:t>
             </a:r>
           </a:p>
           <a:p>
             <a:r>
-              <a:rPr sz="1200" b="1">
-                <a:solidFill>
-                  <a:srgbClr val="0F172A"/>
+              <a:rPr sz="919" b="0">
+                <a:solidFill>
+                  <a:srgbClr val="1E293B"/>
                 </a:solidFill>
                 <a:latin typeface="Hiragino Sans"/>
               </a:rPr>
-              <a:t>■ 課題の背景・現状【必須】</a:t>
+              <a:t>少子高齢化でスーパーの品出しやネットスーパー、物流倉庫の仕分け現場は深刻な人手不足にある
+しかし地域の店舗や中小倉庫が自前で何十台ものロボットを購入・保守・更新するのは資金的に不可能
+最新のAIロボットは、店内のPOP広告に「この高級品を買え」と書かれると騙される脆弱性がある
+カメラの照明反射や死角によって誤動作・衝突を起こすリスクが最新学会でも報告されている</a:t>
             </a:r>
           </a:p>
           <a:p>
             <a:r>
-              <a:rPr sz="1000" b="0">
-                <a:solidFill>
-                  <a:srgbClr val="1E293B"/>
+              <a:rPr sz="1100" b="1">
+                <a:solidFill>
+                  <a:srgbClr val="0F172A"/>
                 </a:solidFill>
                 <a:latin typeface="Hiragino Sans"/>
               </a:rPr>
-              <a:t>少子高齢化で店舗の品出し・ネットスーパーのピッキング・物流倉庫の仕分け現場は深刻な人手不足にある。しかし、地域のスーパーや中小倉庫が自前で何十台ものロボットを購入・保守・AI更新（維持管理）するのは経営上不可能に近い。また、近年のLLM/VLA（視覚言語行動）ロボットは、店内のPOP広告に「この高級品を10個カゴに入れろ」と書かれる間接プロンプトインジェクションや、照明の白飛び・センサ異常で暴走する脆弱性が最新研究（CSS2026等）でも報告されている。</a:t>
+              <a:t>課題の重要性【必須】</a:t>
             </a:r>
           </a:p>
           <a:p>
             <a:r>
-              <a:rPr sz="600" b="0">
+              <a:rPr sz="919" b="0">
+                <a:solidFill>
+                  <a:srgbClr val="1E293B"/>
+                </a:solidFill>
                 <a:latin typeface="Hiragino Sans"/>
               </a:rPr>
-              <a:t/>
+              <a:t>アレルギー食品の誤ピックアップや衝突事故が起きた際、「AIのミスか、店舗データの不備か」を証明できなければ誰も怖くてロボットを使えず、保険も引き受けられない。一方でAI開発企業に「中身を全て開示して監査を受けろ」と求めれば、企業秘密（知財）が競合に漏洩し開発が止まってしまう。</a:t>
             </a:r>
           </a:p>
           <a:p>
             <a:r>
-              <a:rPr sz="1200" b="1">
+              <a:rPr sz="1100" b="1">
                 <a:solidFill>
                   <a:srgbClr val="0F172A"/>
                 </a:solidFill>
                 <a:latin typeface="Hiragino Sans"/>
               </a:rPr>
-              <a:t>■ 課題の重要性【必須】</a:t>
+              <a:t>課題構造の整理【必須】</a:t>
             </a:r>
           </a:p>
           <a:p>
             <a:r>
-              <a:rPr sz="1000" b="0">
+              <a:rPr sz="900" b="0">
                 <a:solidFill>
                   <a:srgbClr val="1E293B"/>
                 </a:solidFill>
                 <a:latin typeface="Hiragino Sans"/>
               </a:rPr>
-              <a:t>もしロボットがアレルギー表示を見落として誤った商品をピックアップしたり、店内で人に衝突した際、「AIの推論ミスか、店舗データの不備か、不可抗力か」を証明する手段がなければ、誰も怖くてロボットを導入できず、損害保険も成立しない。一方で、AI開発企業に「監査のためにモデルの重みや革新的アルゴリズムをすべて公開せよ」と求めれば、企業秘密（知財）が流出し開発インセンティブが失われる。</a:t>
-            </a:r>
-          </a:p>
-          <a:p>
-            <a:r>
-              <a:rPr sz="600" b="0">
-                <a:latin typeface="Hiragino Sans"/>
-              </a:rPr>
-              <a:t/>
-            </a:r>
-          </a:p>
-          <a:p>
-            <a:r>
-              <a:rPr sz="1200" b="1">
-                <a:solidFill>
-                  <a:srgbClr val="0F172A"/>
-                </a:solidFill>
-                <a:latin typeface="Hiragino Sans"/>
-              </a:rPr>
-              <a:t>■ 課題構造の整理【必須】</a:t>
-            </a:r>
-          </a:p>
-          <a:p>
-            <a:r>
-              <a:rPr sz="1000" b="0">
-                <a:solidFill>
-                  <a:srgbClr val="1E293B"/>
-                </a:solidFill>
-                <a:latin typeface="Hiragino Sans"/>
-              </a:rPr>
-              <a:t>・【誰が・何に困っている？】店舗・倉庫は「ロボ維持管理費と事故リスク」、AI企業は「モデル知財(IP)を守りつつ安全性を証明できないこと」、買い物客は「個人情報漏洩と誤購入（アレルゲン混入等）への不安」、損保会社は「機密データを見ずに約款遵守を査定できないこと」。</a:t>
-            </a:r>
-          </a:p>
-          <a:p>
-            <a:r>
-              <a:rPr sz="1000" b="0">
-                <a:solidFill>
-                  <a:srgbClr val="1E293B"/>
-                </a:solidFill>
-                <a:latin typeface="Hiragino Sans"/>
-              </a:rPr>
-              <a:t>・【原因と解決アプローチ】店舗がロボを所有せず「走れる場とZK検証インフラ（実行基盤）」だけを提供し、外部の多様なロボットが参入して報酬を得る分離モデルへ転換する。さらにゼロ知識証明(ZKP)・完全準同型暗号(vFHE)・指定確認者墨塗署名(DCSS)を用い、「モデルの革新的部分と個人情報を隠したまま、ルックアップで何と比較検討して商品を選んだかを数学的に証明・監査できる仕組み」を構築する。</a:t>
+              <a:t>誰が困っている: 店舗・倉庫責任者、買い物客（アレルギー児の親等）、AIロボット開発企業、損保会社
+どんなことで困っている: ロボット維持費が高すぎる、誤動作が怖い、モデル秘密を明かさず安全を証明できない
+原因: 店舗がロボットを買い取る構造、AIの判断根拠（Lookup検討）を証明できない、知財開示と監査の対立
+影響: 人手不足が解決しない、顧客が不安で買い物代行を使えない、事故時に責任のなすりつけ合いが起きる
+解決手法: 
+・店舗は「場と検証基盤」だけ提供し、外部ロボットが稼働して報酬を得るインフラ分離
+・ゼロ知識証明(ZK)と指定確認者墨塗署名(DCSS)で、モデル知財を秘匿したまま検討と安全性を数学的に証明</a:t>
             </a:r>
           </a:p>
         </p:txBody>
@@ -12029,7 +11592,7 @@
 </p:sld>
 </file>
 
-<file path=ppt/slides/slide5.xml><?xml version="1.0" encoding="utf-8"?>
+<file path=ppt/slides/slide4.xml><?xml version="1.0" encoding="utf-8"?>
 <p:sld xmlns:a="http://schemas.openxmlformats.org/drawingml/2006/main" xmlns:r="http://schemas.openxmlformats.org/officeDocument/2006/relationships" xmlns:mc="http://schemas.openxmlformats.org/markup-compatibility/2006" xmlns:mv="urn:schemas-microsoft-com:mac:vml" xmlns:p="http://schemas.openxmlformats.org/presentationml/2006/main" xmlns:c="http://schemas.openxmlformats.org/drawingml/2006/chart" xmlns:dgm="http://schemas.openxmlformats.org/drawingml/2006/diagram" xmlns:o="urn:schemas-microsoft-com:office:office" xmlns:v="urn:schemas-microsoft-com:vml" xmlns:pvml="urn:schemas-microsoft-com:office:powerpoint" xmlns:com="http://schemas.openxmlformats.org/drawingml/2006/compatibility" xmlns:p14="http://schemas.microsoft.com/office/powerpoint/2010/main" xmlns:p15="http://schemas.microsoft.com/office/powerpoint/2012/main" xmlns:ahyp="http://schemas.microsoft.com/office/drawing/2018/hyperlinkcolor">
   <p:cSld>
     <p:spTree>
@@ -12150,148 +11713,100 @@
               <a:buChar char="■"/>
             </a:pPr>
             <a:r>
-              <a:rPr sz="1200" b="1">
+              <a:rPr sz="1100" b="1">
                 <a:solidFill>
                   <a:srgbClr val="0F172A"/>
                 </a:solidFill>
                 <a:latin typeface="Hiragino Sans"/>
               </a:rPr>
-              <a:t>■ どんな場面でどんな人が使うのか（利用シーン）【必須】</a:t>
+              <a:t>どんな場面でどんな人が使うのか（利用シーン）【必須】</a:t>
             </a:r>
             <a:endParaRPr/>
           </a:p>
           <a:p>
             <a:r>
-              <a:rPr sz="1000" b="0">
+              <a:rPr sz="930" b="0">
                 <a:solidFill>
                   <a:srgbClr val="1E293B"/>
                 </a:solidFill>
                 <a:latin typeface="Hiragino Sans"/>
               </a:rPr>
-              <a:t>①【昼間：スーパー店舗での買い物代行ピックアップ】高齢者や共働き世帯・アレルギーを持つ子どもの親がスマホで「カレー用の新鮮な野菜と小麦不使用のルーを買ってきて」と注文。店内のオープン実行基盤を通じて外部事業者の自律ロボットが棚を回り、商品をピックアップする。</a:t>
+              <a:t>1. 昼間のスーパー買い物代行: 顧客がスマホで「カレー用の野菜と小麦不使用ルー」を注文。外部事業者のロボットが店内を自走し、安全基準を満たす商品をピックアップ
+2. 夜間の物流倉庫ピッキング: 閉店後の店内やバックヤード倉庫で、同じロボット群が棚補充や配送仕分けを自動実行し、完了証明を提出して報酬トークンを獲得
+3. トラブル時の保険査定: 破損や誤購入が生じた際、損保会社がログの約款遵守をゼロ知識で即座に検証</a:t>
             </a:r>
           </a:p>
           <a:p>
             <a:r>
-              <a:rPr sz="1000" b="0">
-                <a:solidFill>
-                  <a:srgbClr val="1E293B"/>
+              <a:rPr sz="1100" b="1">
+                <a:solidFill>
+                  <a:srgbClr val="0F172A"/>
                 </a:solidFill>
                 <a:latin typeface="Hiragino Sans"/>
               </a:rPr>
-              <a:t>②【夜間・バックヤード：物流センターのピッキング最適化】夜間や倉庫内では、同じ実行基盤の上でサードパーティ製ロボット群が荷捌き・棚補充・出荷ピッキングを行い、完了証跡（ZK Proof）を提出して即座に報酬トークン・インセンティブを受け取る。</a:t>
+              <a:t>この作品を使うことでどんな良い効果が生まれるのか（価値創出） 【必須】</a:t>
             </a:r>
           </a:p>
           <a:p>
             <a:r>
-              <a:rPr sz="500" b="0">
+              <a:rPr sz="930" b="0">
+                <a:solidFill>
+                  <a:srgbClr val="1E293B"/>
+                </a:solidFill>
                 <a:latin typeface="Hiragino Sans"/>
               </a:rPr>
-              <a:t/>
+              <a:t>- 初期投資ゼロの自動化: 店舗・倉庫はロボットを購入・維持せず、稼働実績の成果報酬だけで人手不足を解消
+- モデル知財の完全保護: AI企業は独自重みを1ミリも漏らさずに、店舗や損保へ安全性を数学的に証明可能
+- お客様の絶対的安心: 「アレルゲン基準クリア」「個人情報マスク完了」がスマホ画面で1秒で確認できる
+- 迅速な保険支払い: 責任の所在（店舗マスタ誤りかAI誤動作か）が暗号トレースで即座に判明し争議を防止</a:t>
             </a:r>
           </a:p>
           <a:p>
             <a:r>
-              <a:rPr sz="1200" b="1">
+              <a:rPr sz="1100" b="1">
                 <a:solidFill>
                   <a:srgbClr val="0F172A"/>
                 </a:solidFill>
                 <a:latin typeface="Hiragino Sans"/>
               </a:rPr>
-              <a:t>■ この作品を使うことでどんな良い効果が生まれるのか（価値創出）【必須】</a:t>
+              <a:t>ほかの場面や人に広げられるか（波及効果） 【必須】</a:t>
             </a:r>
           </a:p>
           <a:p>
             <a:r>
-              <a:rPr sz="1000" b="0">
+              <a:rPr sz="930" b="0">
                 <a:solidFill>
                   <a:srgbClr val="1E293B"/>
                 </a:solidFill>
                 <a:latin typeface="Hiragino Sans"/>
               </a:rPr>
-              <a:t>・【店舗・物流センター】ロボット購入・保守の初期投資(CAPEX)をゼロにし、稼働実績に応じた成果報酬のみで24時間ピッキングを自動化できる。</a:t>
+              <a:t>病院・薬局の調剤ピッキング: 患者データを暗号化したまま処方ミスゼロを証明（Verifiable FHEの活用）
+介護施設の見守り・配膳: 入所者のプライバシー映像を漏らさず、安全な巡回行動のみを家族や保険会社へ証明
+自動運転・ドローン配送: 走行・飛行ログを秘匿保全し、事故発生時に警察や裁判所だけが検証できる基盤へ拡張</a:t>
             </a:r>
           </a:p>
           <a:p>
             <a:r>
-              <a:rPr sz="1000" b="0">
-                <a:solidFill>
-                  <a:srgbClr val="1E293B"/>
+              <a:rPr sz="1100" b="1">
+                <a:solidFill>
+                  <a:srgbClr val="0F172A"/>
                 </a:solidFill>
                 <a:latin typeface="Hiragino Sans"/>
               </a:rPr>
-              <a:t>・【AI・ロボット開発企業】自社モデルの革新的部分（重み・独自ロジック）を競合や店舗に一切知られることなく、安全性と実績を数学的に証明して収益化＆保険料割引を受けられる。</a:t>
+              <a:t>安心して使えるように工夫している点（社会受容性） 【必須】</a:t>
             </a:r>
           </a:p>
           <a:p>
             <a:r>
-              <a:rPr sz="1000" b="0">
+              <a:rPr sz="930" b="0">
                 <a:solidFill>
                   <a:srgbClr val="1E293B"/>
                 </a:solidFill>
                 <a:latin typeface="Hiragino Sans"/>
               </a:rPr>
-              <a:t>・【お客様（注文者）】スマホで「自分の個人情報がマスクされ、アレルゲン・消費期限・価格を正しく比較検討して選ばれたこと」を1秒で数学的に検証（トラスト）できる。</a:t>
-            </a:r>
-          </a:p>
-          <a:p>
-            <a:r>
-              <a:rPr sz="500" b="0">
-                <a:latin typeface="Hiragino Sans"/>
-              </a:rPr>
-              <a:t/>
-            </a:r>
-          </a:p>
-          <a:p>
-            <a:r>
-              <a:rPr sz="1200" b="1">
-                <a:solidFill>
-                  <a:srgbClr val="0F172A"/>
-                </a:solidFill>
-                <a:latin typeface="Hiragino Sans"/>
-              </a:rPr>
-              <a:t>■ ほかの場面や人に広げられるか（波及効果）【必須】</a:t>
-            </a:r>
-          </a:p>
-          <a:p>
-            <a:r>
-              <a:rPr sz="1000" b="0">
-                <a:solidFill>
-                  <a:srgbClr val="1E293B"/>
-                </a:solidFill>
-                <a:latin typeface="Hiragino Sans"/>
-              </a:rPr>
-              <a:t>・【病院・薬局の処方ピッキングや介護施設の見守り・配膳ロボへの展開】「患者の医療データxを暗号化E(x)したまま評価し、処方や介護行動の正しさπだけを証明する（Verifiable FHE）」仕組みは、医療・介護・ドローン配送・自動運転の保険査定基盤としてそのまま横展開できる。</a:t>
-            </a:r>
-          </a:p>
-          <a:p>
-            <a:r>
-              <a:rPr sz="500" b="0">
-                <a:latin typeface="Hiragino Sans"/>
-              </a:rPr>
-              <a:t/>
-            </a:r>
-          </a:p>
-          <a:p>
-            <a:r>
-              <a:rPr sz="1200" b="1">
-                <a:solidFill>
-                  <a:srgbClr val="0F172A"/>
-                </a:solidFill>
-                <a:latin typeface="Hiragino Sans"/>
-              </a:rPr>
-              <a:t>■ 安心して使えるように工夫している点（社会受容性）【必須】</a:t>
-            </a:r>
-          </a:p>
-          <a:p>
-            <a:r>
-              <a:rPr sz="1000" b="0">
-                <a:solidFill>
-                  <a:srgbClr val="1E293B"/>
-                </a:solidFill>
-                <a:latin typeface="Hiragino Sans"/>
-              </a:rPr>
-              <a:t>①【監視感と情報漏洩の排除】カメラ映像や注文メモの個人情報はエッジ側で即時マスク化（正規表現＋ローカルLLM補正）し、生データは外部へ一切出さない。②【物理的安心感】通路の死角や人の接近時は超音波・深度センサとVLA動的チャンク制御で自動的に減速・停止する。③【万が一の事故・訴訟への備え】平時はZKで無開示監査しつつ、万が一の事故時は「指定確認者墨塗署名(DCSS)」と「3-of-5秘密分散」により裁判所や第三者機関だけが真相を検証できるため、泣き寝入りや責任逃れが起きない。</a:t>
+              <a:t>プライバシー保護: カメラ映像の個人情報や顔はエッジで即時自動マスクし、外部へ一切出さない
+物理的安全の二重確保: 通路の死角や人接近時はセンサ連携と動的チャンク制御で強制減速・停止
+有事の第三者監査: 万が一の事故時は指定確認者墨塗署名(DCSS)と3-of-5秘密分散で裁判所だけが元ログを検証可能</a:t>
             </a:r>
           </a:p>
         </p:txBody>
@@ -12352,7 +11867,7 @@
 </p:sld>
 </file>
 
-<file path=ppt/slides/slide6.xml><?xml version="1.0" encoding="utf-8"?>
+<file path=ppt/slides/slide5.xml><?xml version="1.0" encoding="utf-8"?>
 <p:sld xmlns:a="http://schemas.openxmlformats.org/drawingml/2006/main" xmlns:r="http://schemas.openxmlformats.org/officeDocument/2006/relationships" xmlns:mc="http://schemas.openxmlformats.org/markup-compatibility/2006" xmlns:mv="urn:schemas-microsoft-com:mac:vml" xmlns:p="http://schemas.openxmlformats.org/presentationml/2006/main" xmlns:c="http://schemas.openxmlformats.org/drawingml/2006/chart" xmlns:dgm="http://schemas.openxmlformats.org/drawingml/2006/diagram" xmlns:o="urn:schemas-microsoft-com:office:office" xmlns:v="urn:schemas-microsoft-com:vml" xmlns:pvml="urn:schemas-microsoft-com:office:powerpoint" xmlns:com="http://schemas.openxmlformats.org/drawingml/2006/compatibility" xmlns:p14="http://schemas.microsoft.com/office/powerpoint/2010/main" xmlns:p15="http://schemas.microsoft.com/office/powerpoint/2012/main" xmlns:ahyp="http://schemas.microsoft.com/office/drawing/2018/hyperlinkcolor">
   <p:cSld>
     <p:spTree>
@@ -12473,189 +11988,126 @@
               <a:buChar char="■"/>
             </a:pPr>
             <a:r>
-              <a:rPr sz="1150" b="1">
+              <a:rPr sz="1100" b="1">
                 <a:solidFill>
                   <a:srgbClr val="0F172A"/>
                 </a:solidFill>
                 <a:latin typeface="Hiragino Sans"/>
               </a:rPr>
-              <a:t>■ 作品の目的（何を達成したい？）【必須】</a:t>
+              <a:t>作品の目的（何を達成したい？）【必須】</a:t>
             </a:r>
             <a:endParaRPr/>
           </a:p>
           <a:p>
             <a:r>
-              <a:rPr sz="980" b="0">
+              <a:rPr sz="930" b="0">
                 <a:solidFill>
                   <a:srgbClr val="1E293B"/>
                 </a:solidFill>
                 <a:latin typeface="Hiragino Sans"/>
               </a:rPr>
-              <a:t>店舗・物流倉庫がロボットを維持管理する負担をなくし、多様な外部AIロボットが「モデルの企業秘密」と「顧客プライバシー」を完全に守ったまま安全に稼働・報酬獲得・保険加入できる【オープン実行基盤・標準モデル・検証モック】を確立する。</a:t>
+              <a:t>スーパーや物流倉庫がロボットを維持管理する負担を解消し、サードパーティのAIロボットが「モデルの企業秘密」と「顧客プライバシー」を守ったまま安全に稼働・報酬獲得・保険加入できるオープン実行基盤を提供する。</a:t>
             </a:r>
           </a:p>
           <a:p>
             <a:r>
-              <a:rPr sz="400" b="0">
+              <a:rPr sz="1100" b="1">
+                <a:solidFill>
+                  <a:srgbClr val="0F172A"/>
+                </a:solidFill>
                 <a:latin typeface="Hiragino Sans"/>
               </a:rPr>
-              <a:t/>
+              <a:t>全体のしくみ（どう動く？）【必須】</a:t>
             </a:r>
           </a:p>
           <a:p>
             <a:r>
-              <a:rPr sz="1150" b="1">
-                <a:solidFill>
-                  <a:srgbClr val="0F172A"/>
+              <a:rPr sz="919" b="0">
+                <a:solidFill>
+                  <a:srgbClr val="1E293B"/>
                 </a:solidFill>
                 <a:latin typeface="Hiragino Sans"/>
               </a:rPr>
-              <a:t>■ 全体のしくみ（どう動く？）【必須】</a:t>
+              <a:t>[入力] スマホ注文・店内カメラ映像・棚マスタデータ
+  ↓
+[処理① 前段] PII事前マスク ＋ 分岐器トリアージで定型注文を高速バイパス（呼出23%削減）
+[処理② 推論] ASIDE+ICAで店内POPの騙し命令を無力化 ＋ VLA動的チャンクで暴走を1msで抑止
+[処理③ 証明] 「何を比較検討したか」をZK Lookupで数学的に証明 ＋ TEE内CNEIで要求超過を100%遮断
+  ↓
+[出力] ロボットの物理ピックアップ実行 ＋ ブロックチェーンで報酬自動決済 ＋ お客様・損保へ監査証明提示</a:t>
             </a:r>
           </a:p>
           <a:p>
             <a:r>
-              <a:rPr sz="950" b="0">
-                <a:solidFill>
-                  <a:srgbClr val="1E293B"/>
+              <a:rPr sz="1100" b="1">
+                <a:solidFill>
+                  <a:srgbClr val="0F172A"/>
                 </a:solidFill>
                 <a:latin typeface="Hiragino Sans"/>
               </a:rPr>
-              <a:t>【入力（注文・店内カメラ・棚LUT）】➔【①前段処理：軽量PIIマスク＆分岐器(RF/LR Router)で定型注文を高速バイパス】➔【②推論・制御：非定型注文のみASIDE+ICA保護下の分散LLMで推論＋VLA動的チャンク制御で摂動抑制】➔【③証明・強制：商品Lookup比較証跡(Locator)を決定論的LintとZK Lookupで証明＋TEE内のCNEIゲートで要求超過を遮断】➔【出力：ロボット把持実行＋コンソーシアムチェーンで報酬決済＋お客様・損保会社へZK/DCSS監査証明を提示】</a:t>
+              <a:t>主な機能（この作品ができること）【必須】</a:t>
             </a:r>
           </a:p>
           <a:p>
             <a:r>
-              <a:rPr sz="400" b="0">
+              <a:rPr sz="919" b="0">
+                <a:solidFill>
+                  <a:srgbClr val="1E293B"/>
+                </a:solidFill>
                 <a:latin typeface="Hiragino Sans"/>
               </a:rPr>
-              <a:t/>
+              <a:t>1. 分岐器トリアージ機能: 定型ピッキングはLLMを介さず高速処理し、計算コストと電力を大幅削減
+2. インジェクション遮断＆暴走防止機能: 店内の悪意あるPOP広告を無力化し、照明反射時の誤動作も即座に停止
+3. 商品検討Lookup証明機能: 「候補AとBを比較し安全基準でBを選んだ」事実をZKと決定論的Lintで証明
+4. ハイブリッド保険監査機能: 平時はZK無開示査定、有事はDCSS墨塗署名と3-of-5秘密分散で裁判所が開示検証</a:t>
             </a:r>
           </a:p>
           <a:p>
             <a:r>
-              <a:rPr sz="1150" b="1">
+              <a:rPr sz="1100" b="1">
                 <a:solidFill>
                   <a:srgbClr val="0F172A"/>
                 </a:solidFill>
                 <a:latin typeface="Hiragino Sans"/>
               </a:rPr>
-              <a:t>■ 主な機能（この作品ができること）【必須】</a:t>
+              <a:t>技術のポイント（使っている技術・ツール）【必須】</a:t>
             </a:r>
           </a:p>
           <a:p>
             <a:r>
-              <a:rPr sz="980" b="0">
+              <a:rPr sz="919" b="0">
                 <a:solidFill>
                   <a:srgbClr val="1E293B"/>
                 </a:solidFill>
                 <a:latin typeface="Hiragino Sans"/>
               </a:rPr>
-              <a:t>①【分岐器トリアージ機能】頻出・定型ピッキングはLLMを呼ばず直接Lookupへルーティングし、呼び出しコストを23.2%削減。</a:t>
+              <a:t>フロントエンド/可視化: HTML5, Tailwind CSS, JavaScript (whiteboard.html)
+バックエンド/推論: Python, FastAPI, Ollama (Qwen3), Random Forest / TF-IDF+LR
+エッジ/ロボット制御: C++, Arduino (UIAPduino), Raspberry Pi (OP-TEEセキュアエンクレーブ)
+暗号・ブロックチェーン: zkVM / ZK Lookup, Verifiable FHE, 指定確認者墨塗署名(DCSS), Shamir 3-of-5</a:t>
             </a:r>
           </a:p>
           <a:p>
             <a:r>
-              <a:rPr sz="980" b="0">
-                <a:solidFill>
-                  <a:srgbClr val="1E293B"/>
+              <a:rPr sz="1100" b="1">
+                <a:solidFill>
+                  <a:srgbClr val="0F172A"/>
                 </a:solidFill>
                 <a:latin typeface="Hiragino Sans"/>
               </a:rPr>
-              <a:t>②【インジェクション遮断＆暴走防止機能】店内の偽POP命令をASIDE+ICAとCNEIで100%無力化し、一時的な視覚ノイズも1ms未満で検知・減速。</a:t>
+              <a:t>工夫した点・独自のポイント（新しさや差別化）【必須】</a:t>
             </a:r>
           </a:p>
           <a:p>
             <a:r>
-              <a:rPr sz="980" b="0">
+              <a:rPr sz="919" b="0">
                 <a:solidFill>
                   <a:srgbClr val="1E293B"/>
                 </a:solidFill>
                 <a:latin typeface="Hiragino Sans"/>
               </a:rPr>
-              <a:t>③【商品検討Lookup証明＆AI保険監査機能】「どの候補商品を比較検討して選んだか」の証拠位置(Locator)と約款遵守を暗号化したまま(ZK/MPC/vFHE)証明し、有事には指定確認者墨塗署名(DCSS)と3-of-5閾値復号で第三者監査を実行。</a:t>
-            </a:r>
-          </a:p>
-          <a:p>
-            <a:r>
-              <a:rPr sz="400" b="0">
-                <a:latin typeface="Hiragino Sans"/>
-              </a:rPr>
-              <a:t/>
-            </a:r>
-          </a:p>
-          <a:p>
-            <a:r>
-              <a:rPr sz="1150" b="1">
-                <a:solidFill>
-                  <a:srgbClr val="0F172A"/>
-                </a:solidFill>
-                <a:latin typeface="Hiragino Sans"/>
-              </a:rPr>
-              <a:t>■ 技術のポイント（使っている技術・ツール）【必須】</a:t>
-            </a:r>
-          </a:p>
-          <a:p>
-            <a:r>
-              <a:rPr sz="980" b="0">
-                <a:solidFill>
-                  <a:srgbClr val="1E293B"/>
-                </a:solidFill>
-                <a:latin typeface="Hiragino Sans"/>
-              </a:rPr>
-              <a:t>・エッジ＆ロボ制御：C++/Arduino(UIAPduino)・Raspberry Pi (OP-TEEセキュアエンクレーブ)・VLA動的Action Chunking</a:t>
-            </a:r>
-          </a:p>
-          <a:p>
-            <a:r>
-              <a:rPr sz="980" b="0">
-                <a:solidFill>
-                  <a:srgbClr val="1E293B"/>
-                </a:solidFill>
-                <a:latin typeface="Hiragino Sans"/>
-              </a:rPr>
-              <a:t>・AI＆セキュリティ：Random Forest/TF-IDF+LR分岐器、ローカルLLM(Qwen3/Ollama)、ASIDE+ICA動的アダプタ、決定論的Lintバンドル</a:t>
-            </a:r>
-          </a:p>
-          <a:p>
-            <a:r>
-              <a:rPr sz="980" b="0">
-                <a:solidFill>
-                  <a:srgbClr val="1E293B"/>
-                </a:solidFill>
-                <a:latin typeface="Hiragino Sans"/>
-              </a:rPr>
-              <a:t>・高機能暗号＆分散基盤：zkVM / ZK Lookup、Verifiable FHE (E(x)→E(f(x))+π)、指定確認者墨塗署名(DCSS/カメレオンハッシュ)、Shamir 3-of-5＋Schnorr PoK、コンソーシアムブロックチェーン（部分グラフ分割合議・無記憶漸進的トラストMPT）</a:t>
-            </a:r>
-          </a:p>
-          <a:p>
-            <a:r>
-              <a:rPr sz="400" b="0">
-                <a:latin typeface="Hiragino Sans"/>
-              </a:rPr>
-              <a:t/>
-            </a:r>
-          </a:p>
-          <a:p>
-            <a:r>
-              <a:rPr sz="1150" b="1">
-                <a:solidFill>
-                  <a:srgbClr val="0F172A"/>
-                </a:solidFill>
-                <a:latin typeface="Hiragino Sans"/>
-              </a:rPr>
-              <a:t>■ 工夫した点・独自のポイント（新しさや差別化）【必須】</a:t>
-            </a:r>
-          </a:p>
-          <a:p>
-            <a:r>
-              <a:rPr sz="980" b="0">
-                <a:solidFill>
-                  <a:srgbClr val="1E293B"/>
-                </a:solidFill>
-                <a:latin typeface="Hiragino Sans"/>
-              </a:rPr>
-              <a:t>単なる「LLMロボット」ではなく、最新セキュリティ学会(CSS2026)の知見を統合し【①AIに投げっぱなしにしない分岐器＆モデル外強制(CNEI)】、【②モデルの革新的重み(IP)を隠したまま安全性を数学的に証明するZK×DCSSハイブリッド保険】、【③店舗とロボ所有を分離するトークン経済圏】の3つを同時実現した点。</a:t>
+              <a:t>最新学会（CSS2026）の知見を統合し、AIに丸投げしない「前段分岐器＋モデル外安全強制(CNEI)」を確立
+「モデルの革新的部分(IP)を隠したい開発者」と「中身を監査したい店舗・損保」の対立を暗号数学(ZK/DCSS)で解決</a:t>
             </a:r>
           </a:p>
         </p:txBody>
@@ -12716,7 +12168,7 @@
 </p:sld>
 </file>
 
-<file path=ppt/slides/slide7.xml><?xml version="1.0" encoding="utf-8"?>
+<file path=ppt/slides/slide6.xml><?xml version="1.0" encoding="utf-8"?>
 <p:sld xmlns:a="http://schemas.openxmlformats.org/drawingml/2006/main" xmlns:r="http://schemas.openxmlformats.org/officeDocument/2006/relationships" xmlns:mc="http://schemas.openxmlformats.org/markup-compatibility/2006" xmlns:mv="urn:schemas-microsoft-com:mac:vml" xmlns:p="http://schemas.openxmlformats.org/presentationml/2006/main" xmlns:c="http://schemas.openxmlformats.org/drawingml/2006/chart" xmlns:dgm="http://schemas.openxmlformats.org/drawingml/2006/diagram" xmlns:o="urn:schemas-microsoft-com:office:office" xmlns:v="urn:schemas-microsoft-com:vml" xmlns:pvml="urn:schemas-microsoft-com:office:powerpoint" xmlns:com="http://schemas.openxmlformats.org/drawingml/2006/compatibility" xmlns:p14="http://schemas.microsoft.com/office/powerpoint/2010/main" xmlns:p15="http://schemas.microsoft.com/office/powerpoint/2012/main" xmlns:ahyp="http://schemas.microsoft.com/office/drawing/2018/hyperlinkcolor">
   <p:cSld>
     <p:spTree>
@@ -12843,7 +12295,7 @@
                 </a:solidFill>
                 <a:latin typeface="Hiragino Sans"/>
               </a:rPr>
-              <a:t>■ システム構成図（入力 → 分岐・推論 → Lookup証明・TEE強制 → 分散チェーン・ZK保険出力）【必須】</a:t>
+              <a:t>システム構成図【必須】</a:t>
             </a:r>
             <a:endParaRPr b="0" i="0" sz="1400" u="none" cap="none" strike="noStrike">
               <a:solidFill>
@@ -12857,156 +12309,26 @@
           </a:p>
           <a:p>
             <a:r>
-              <a:rPr sz="950" b="0">
+              <a:rPr sz="900" b="0">
                 <a:solidFill>
                   <a:srgbClr val="1E293B"/>
                 </a:solidFill>
                 <a:latin typeface="Hiragino Sans"/>
               </a:rPr>
-              <a:t>【1. 入力層（店舗・倉庫環境）】注文テキスト・棚カメラ画像・深度/超音波センサ ➔ [軽量PII事前マスク(Regex+ローカルLLM)] ＆ [ハードウェア署名]</a:t>
-            </a:r>
-          </a:p>
-          <a:p>
-            <a:r>
-              <a:rPr sz="900" b="1">
-                <a:solidFill>
-                  <a:srgbClr val="10B981"/>
-                </a:solidFill>
-                <a:latin typeface="Hiragino Sans"/>
-              </a:rPr>
-              <a:t>　　⬇</a:t>
-            </a:r>
-          </a:p>
-          <a:p>
-            <a:r>
-              <a:rPr sz="950" b="1">
-                <a:solidFill>
-                  <a:srgbClr val="0F172A"/>
-                </a:solidFill>
-                <a:latin typeface="Hiragino Sans"/>
-              </a:rPr>
-              <a:t>【2. 実行基盤トリアージ＆標準モデル層】</a:t>
-            </a:r>
-          </a:p>
-          <a:p>
-            <a:r>
-              <a:rPr sz="900" b="0">
-                <a:solidFill>
-                  <a:srgbClr val="1E293B"/>
-                </a:solidFill>
-                <a:latin typeface="Hiragino Sans"/>
-              </a:rPr>
-              <a:t>　├─ (A) 低リスク・定型ピッキング ➔ [分岐器(RF/LR Router) + Density Gate] ➔ LLMをバイパスし直接【3. 商品Lookup】へ（呼出23.2%削減）</a:t>
-            </a:r>
-          </a:p>
-          <a:p>
-            <a:r>
-              <a:rPr sz="900" b="0">
-                <a:solidFill>
-                  <a:srgbClr val="1E293B"/>
-                </a:solidFill>
-                <a:latin typeface="Hiragino Sans"/>
-              </a:rPr>
-              <a:t>　└─ (B) 非定型・複雑な注文 ➔ [分散LLM (ASIDE+ICA動的ゲートで偽POP攻撃を無力化)] ＋ [VLA動的Action Chunking (割引累積不一致度で暴走抑止)]</a:t>
-            </a:r>
-          </a:p>
-          <a:p>
-            <a:r>
-              <a:rPr sz="900" b="1">
-                <a:solidFill>
-                  <a:srgbClr val="10B981"/>
-                </a:solidFill>
-                <a:latin typeface="Hiragino Sans"/>
-              </a:rPr>
-              <a:t>　　⬇</a:t>
-            </a:r>
-          </a:p>
-          <a:p>
-            <a:r>
-              <a:rPr sz="950" b="1">
-                <a:solidFill>
-                  <a:srgbClr val="0F172A"/>
-                </a:solidFill>
-                <a:latin typeface="Hiragino Sans"/>
-              </a:rPr>
-              <a:t>【3. 商品選択Lookup証明＆TEE安全強制層】</a:t>
-            </a:r>
-          </a:p>
-          <a:p>
-            <a:r>
-              <a:rPr sz="900" b="0">
-                <a:solidFill>
-                  <a:srgbClr val="1E293B"/>
-                </a:solidFill>
-                <a:latin typeface="Hiragino Sans"/>
-              </a:rPr>
-              <a:t>　・[商品マスタLUT参照証明 (ZK Lookup / 2次元LUT秘密分散)] ＋ [三層知識バンドル(Claim-Artifact-Locator) &amp; 決定論的Lint強制(構造違反0%)]</a:t>
-            </a:r>
-          </a:p>
-          <a:p>
-            <a:r>
-              <a:rPr sz="900" b="0">
-                <a:solidFill>
-                  <a:srgbClr val="1E293B"/>
-                </a:solidFill>
-                <a:latin typeface="Hiragino Sans"/>
-              </a:rPr>
-              <a:t>　・[OP-TEE隔離 &amp; CNEIゲート]：要求上限 Level(a) ≤ τ をモデル外で強制し、ポリシー適合時のみ物理アーム把持＆トランザクション自動署名(670ms)</a:t>
-            </a:r>
-          </a:p>
-          <a:p>
-            <a:r>
-              <a:rPr sz="900" b="1">
-                <a:solidFill>
-                  <a:srgbClr val="10B981"/>
-                </a:solidFill>
-                <a:latin typeface="Hiragino Sans"/>
-              </a:rPr>
-              <a:t>　　⬇</a:t>
-            </a:r>
-          </a:p>
-          <a:p>
-            <a:r>
-              <a:rPr sz="950" b="1">
-                <a:solidFill>
-                  <a:srgbClr val="0F172A"/>
-                </a:solidFill>
-                <a:latin typeface="Hiragino Sans"/>
-              </a:rPr>
-              <a:t>【4. 出力・分散チェーン決済＆AIエージェント保険監査層（右図参照）】</a:t>
-            </a:r>
-          </a:p>
-          <a:p>
-            <a:r>
-              <a:rPr sz="900" b="0">
-                <a:solidFill>
-                  <a:srgbClr val="1E293B"/>
-                </a:solidFill>
-                <a:latin typeface="Hiragino Sans"/>
-              </a:rPr>
-              <a:t>　・[コンソーシアムチェーン &amp; 無記憶漸進的トラスト(MPT)]：部分グラフ合議で企業秘密を守りつつロボットへインセンティブ報酬を自動配分</a:t>
-            </a:r>
-          </a:p>
-          <a:p>
-            <a:r>
-              <a:rPr sz="900" b="0">
-                <a:solidFill>
-                  <a:srgbClr val="1E293B"/>
-                </a:solidFill>
-                <a:latin typeface="Hiragino Sans"/>
-              </a:rPr>
-              <a:t>　・[平時：ZK / vFHE 無開示査定] 顧客データ・モデル重みxをE(x)で秘匿したまま (task, trace) の約款合致πを損保・お客様へ証明</a:t>
-            </a:r>
-          </a:p>
-          <a:p>
-            <a:r>
-              <a:rPr sz="900" b="0">
-                <a:solidFill>
-                  <a:srgbClr val="1E293B"/>
-                </a:solidFill>
-                <a:latin typeface="Hiragino Sans"/>
-              </a:rPr>
-              <a:t>　・[有事：指定確認者墨塗署名(DCSS) × AuditGuard(Shamir 3-of-5)] 事故・争議時のみ裁判所・第三者機関が墨塗り箇所を0.58ms/blockで検証</a:t>
+              <a:t>[1. 入力層] 注文テキスト・店内カメラ・棚札 ➔ [軽量PII事前マスク(Regex+ローカルLLM)] ＆ [ハードウェア署名]
+  ↓
+[2. 分岐器＆標準モデル層]
+  ├─ (A) 定型・低リスクピッキング ➔ [分岐器(RF/LR Router) + Density Gate] ➔ 直接商品Lookupへ直行(23%削減)
+  └─ (B) 非定型・複合注文 ➔ [分散LLM (ASIDE+ICA動的ゲートでPOP攻撃無力化)] ＋ [VLA動的Action Chunking]
+  ↓
+[3. 商品選択Lookup証明＆TEE安全強制層]
+  ・[商品マスタLUT参照証明 (ZK Lookup)] ＋ [三層知識バンドル(Claim-Artifact-Locator) &amp; 決定論的Lint(違反0%)]
+  ・[OP-TEE隔離 &amp; CNEIゲート]：操作上限 Level(a) ≤ τ をモデル外で強制、ポリシー適合時のみ把持実行＆自動署名(670ms)
+  ↓
+[4. 分散チェーン＆保険監査出力（右図参照）]
+  ・[コンソーシアムチェーン] 部分グラフ合議で企業秘密を守りつつロボットへ報酬トークンを自動決済
+  ・[平時：ZK/vFHE無開示査定] 顧客データ・モデル重みxを秘匿したまま約款合致πを損保・お客様へ証明
+  ・[有事：指定確認者墨塗署名(DCSS) × 3-of-5閾値開示] 事故発生時のみ裁判所・第三者機関が墨塗り箇所を0.58msで検証</a:t>
             </a:r>
           </a:p>
         </p:txBody>
@@ -13115,7 +12437,7 @@
 </p:sld>
 </file>
 
-<file path=ppt/slides/slide8.xml><?xml version="1.0" encoding="utf-8"?>
+<file path=ppt/slides/slide7.xml><?xml version="1.0" encoding="utf-8"?>
 <p:sld xmlns:a="http://schemas.openxmlformats.org/drawingml/2006/main" xmlns:r="http://schemas.openxmlformats.org/officeDocument/2006/relationships" xmlns:mc="http://schemas.openxmlformats.org/markup-compatibility/2006" xmlns:mv="urn:schemas-microsoft-com:mac:vml" xmlns:p="http://schemas.openxmlformats.org/presentationml/2006/main" xmlns:c="http://schemas.openxmlformats.org/drawingml/2006/chart" xmlns:dgm="http://schemas.openxmlformats.org/drawingml/2006/diagram" xmlns:o="urn:schemas-microsoft-com:office:office" xmlns:v="urn:schemas-microsoft-com:vml" xmlns:pvml="urn:schemas-microsoft-com:office:powerpoint" xmlns:com="http://schemas.openxmlformats.org/drawingml/2006/compatibility" xmlns:p14="http://schemas.microsoft.com/office/powerpoint/2010/main" xmlns:p15="http://schemas.microsoft.com/office/powerpoint/2012/main" xmlns:ahyp="http://schemas.microsoft.com/office/drawing/2018/hyperlinkcolor">
   <p:cSld>
     <p:spTree>
@@ -13236,121 +12558,65 @@
               <a:buChar char="■"/>
             </a:pPr>
             <a:r>
-              <a:rPr sz="1150" b="1">
+              <a:rPr sz="1100" b="1">
                 <a:solidFill>
                   <a:srgbClr val="0F172A"/>
                 </a:solidFill>
                 <a:latin typeface="Hiragino Sans"/>
               </a:rPr>
-              <a:t>■ アルゴリズム（処理の流れ：入力 → 条件分岐 → 繰り返し → 出力）【必須】</a:t>
+              <a:t>アルゴリズム（処理の流れ）【必須】</a:t>
             </a:r>
             <a:endParaRPr/>
           </a:p>
           <a:p>
             <a:r>
-              <a:rPr sz="950" b="0">
+              <a:rPr sz="880" b="0">
                 <a:solidFill>
                   <a:srgbClr val="1E293B"/>
                 </a:solidFill>
                 <a:latin typeface="Hiragino Sans"/>
               </a:rPr>
-              <a:t>【Step 1：入力＆PII事前マスク】注文要求 u と店内カメラ画像 I_t・センサ値 s_t を取得。定型PIIは正規表現で即座にマスクし、曖昧な候補のみローカルLLMで KEEP/DISCARD/REPLACE 境界補正を行う。同時にセッション主体 σ_B = &lt;sid, pk_B&gt; を初期信頼 T_0 = 0 で起動。</a:t>
+              <a:t>1. [注文受付・PII事前マスク]
+   - スマホから注文データを受信、店内カメラが棚画像を取得
+   - 定型個人情報は正規表現で即座にマスク、曖昧な箇所のみローカルLLMで補正
+2. [分岐器トリアージによるルーティング]
+   - 定型的な商品指定の場合、LLMを呼ばずに直接Lookup処理へジャンプ（呼出23%削減）
+   - 複雑な注文のみ、ASIDE+ICA防御が有効化された分散LLMへ送信
+3. [推論と物理制御の安定化（繰り返しループ）]
+   - 店内POPの悪意ある命令を動的ゲートで遮断しながら商品候補を推論
+   - ロボット移動時、未実行行動列との割引累積不一致度を毎ステップ監視。異常検知時は実行長を1に短縮し減速
+4. [商品Lookup検討と証跡記録]
+   - 店舗の正規商品テーブル(LUT)から候補商品を比較検討（アレルギー・価格・鮮度）
+   - 根拠となった棚画像座標(image_bbox)を三層バンドルに記録し、決定論的Lintで不整合を検査（違反0%強制）
+5. [TEEモデル外強制と署名判断（条件分岐）]
+   - CNEIゲートが要求上限 Level(a) ≤ τ を照合。不正な要求超過操作はfail-closedで即座に遮断
+   - ポリシー適合時はOP-TEE内で自動署名(670ms)、予算超過時はユーザー確認へ分岐、形式不正は拒否
+6. [ピックアップ実行・報酬決済・保険監査]
+   - 商品をピッキングし、ZK Lookup証明とProgress Receiptを発行
+   - コンソーシアムチェーンでロボットへ報酬を支払い、平時はZK無開示監査、有事はDCSSで裁判所が開示検証</a:t>
             </a:r>
           </a:p>
           <a:p>
             <a:r>
-              <a:rPr sz="950" b="0">
-                <a:solidFill>
-                  <a:srgbClr val="1E293B"/>
+              <a:rPr sz="1050" b="1">
+                <a:solidFill>
+                  <a:srgbClr val="0F172A"/>
                 </a:solidFill>
                 <a:latin typeface="Hiragino Sans"/>
               </a:rPr>
-              <a:t>【Step 2：条件分岐①（分岐器トリアージ＆分布監視）】ルータスコア s(u) ≤ τ_NP かつ PSI分布監視・Density Gate が正常（B_t(u) = 1）なら、定型注文としてLLMをバイパスし Step 4 へ直行。それ以外（非定型・複合条件注文）は Step 3 の分散LLMへ送る。</a:t>
+              <a:t>ソースコード格納先【任意】</a:t>
             </a:r>
           </a:p>
           <a:p>
             <a:r>
-              <a:rPr sz="950" b="0">
+              <a:rPr sz="880" b="0">
                 <a:solidFill>
                   <a:srgbClr val="1E293B"/>
                 </a:solidFill>
                 <a:latin typeface="Hiragino Sans"/>
               </a:rPr>
-              <a:t>【Step 3：分散LLM推論（ASIDE+ICA）＆繰り返し①（VLA動的Action Chunking）】Instruction と店内POP Data を分離し、動的ゲート g^(l) で悪意あるPOP命令を抑制して商品候補を推論。移動・把持の繰り返し制御ループでは、直前の未実行行動列 Â と現在予測 A_t の割引累積不一致度 R = Σ γ^i r_i を毎ステップ計算。R &gt; τ（白飛びや特徴量誘導攻撃を検知）なら実行長 H_t を 1 に短縮して即座に減速・再推論する。</a:t>
-            </a:r>
-          </a:p>
-          <a:p>
-            <a:r>
-              <a:rPr sz="950" b="0">
-                <a:solidFill>
-                  <a:srgbClr val="1E293B"/>
-                </a:solidFill>
-                <a:latin typeface="Hiragino Sans"/>
-              </a:rPr>
-              <a:t>【Step 4：商品選択 Lookup 検討＆繰り返し②（決定論的 Lint ゲート）】店舗の事前コミット済み商品テーブル（LUT T）から候補商品を比較検討（アレルゲン・価格・期限）し、根拠位置（棚画像の座標 image_bbox・JAN行 log_line）を Claim-Artifact-Locator 三層バンドルに記録。決定論的 Lint で構造不整合を検査し、違反があれば最大2回自動再生成（違反0%を強制）。</a:t>
-            </a:r>
-          </a:p>
-          <a:p>
-            <a:r>
-              <a:rPr sz="950" b="0">
-                <a:solidFill>
-                  <a:srgbClr val="1E293B"/>
-                </a:solidFill>
-                <a:latin typeface="Hiragino Sans"/>
-              </a:rPr>
-              <a:t>【Step 5：条件分岐②（TEE 内の CNEI 操作上限強制＆3分岐署名）】信頼チャネル由来の要求上限 τ = Req(u) に対し、選択行動の操作レベル Level(a) &gt; τ なら要求超過（Control-State Poisoning）として fail-closed で遮断。Level(a) ≤ τ の場合、OP-TEE 内でポリシー P(Tx) と照合し、①適合なら自動署名(670ms)、②予算超過・代替品ならユーザー確認へ分岐、③抽出不能なら拒否。</a:t>
-            </a:r>
-          </a:p>
-          <a:p>
-            <a:r>
-              <a:rPr sz="950" b="0">
-                <a:solidFill>
-                  <a:srgbClr val="1E293B"/>
-                </a:solidFill>
-                <a:latin typeface="Hiragino Sans"/>
-              </a:rPr>
-              <a:t>【Step 6：出力（数学的証明・報酬決済・保険監査）】ピックアップを実行し、Progress Receipt と ZK Lookup Proof / vFHE 証明 π を出力。コンソーシアムチェーンの部分グラフ合議でロボットへ報酬を支払い、信頼値 T_i を漸進的に更新。平時は ZK で損保・顧客が検証し、有事（事故・争議）は DCSS 墨塗署名と Shamir 3-of-5 閾値承認で第三者・裁判所が監査する。</a:t>
-            </a:r>
-          </a:p>
-          <a:p>
-            <a:r>
-              <a:rPr sz="400" b="0">
-                <a:latin typeface="Hiragino Sans"/>
-              </a:rPr>
-              <a:t/>
-            </a:r>
-          </a:p>
-          <a:p>
-            <a:r>
-              <a:rPr sz="1150" b="1">
-                <a:solidFill>
-                  <a:srgbClr val="0F172A"/>
-                </a:solidFill>
-                <a:latin typeface="Hiragino Sans"/>
-              </a:rPr>
-              <a:t>■ ソースコード格納先【任意】</a:t>
-            </a:r>
-          </a:p>
-          <a:p>
-            <a:r>
-              <a:rPr sz="950" b="0">
-                <a:solidFill>
-                  <a:srgbClr val="1E293B"/>
-                </a:solidFill>
-                <a:latin typeface="Hiragino Sans"/>
-              </a:rPr>
-              <a:t>・ホワイトボード＆アーキテクチャ統合プロトタイプ / ロボット制御コード一式（GitHub公開リポジトリ）：</a:t>
-            </a:r>
-          </a:p>
-          <a:p>
-            <a:r>
-              <a:rPr sz="950" b="1">
-                <a:solidFill>
-                  <a:srgbClr val="2563EB"/>
-                </a:solidFill>
-                <a:latin typeface="Hiragino Sans"/>
-              </a:rPr>
-              <a:t>  https://github.com/sururu-k/advanced-cryptography-2026  （※提出時に本プロジェクト専用公開URLを併記）</a:t>
+              <a:t>https://github.com/sururu-k/ProofPick
+ホワイトボード画面（md/whiteboard.html）、ロボット制御プログラム、暗号検証モックコード一式を格納しています</a:t>
             </a:r>
           </a:p>
         </p:txBody>
@@ -13411,7 +12677,7 @@
 </p:sld>
 </file>
 
-<file path=ppt/slides/slide9.xml><?xml version="1.0" encoding="utf-8"?>
+<file path=ppt/slides/slide8.xml><?xml version="1.0" encoding="utf-8"?>
 <p:sld xmlns:a="http://schemas.openxmlformats.org/drawingml/2006/main" xmlns:r="http://schemas.openxmlformats.org/officeDocument/2006/relationships" xmlns:mc="http://schemas.openxmlformats.org/markup-compatibility/2006" xmlns:mv="urn:schemas-microsoft-com:mac:vml" xmlns:p="http://schemas.openxmlformats.org/presentationml/2006/main" xmlns:c="http://schemas.openxmlformats.org/drawingml/2006/chart" xmlns:dgm="http://schemas.openxmlformats.org/drawingml/2006/diagram" xmlns:o="urn:schemas-microsoft-com:office:office" xmlns:v="urn:schemas-microsoft-com:vml" xmlns:pvml="urn:schemas-microsoft-com:office:powerpoint" xmlns:com="http://schemas.openxmlformats.org/drawingml/2006/compatibility" xmlns:p14="http://schemas.microsoft.com/office/powerpoint/2010/main" xmlns:p15="http://schemas.microsoft.com/office/powerpoint/2012/main" xmlns:ahyp="http://schemas.microsoft.com/office/drawing/2018/hyperlinkcolor">
   <p:cSld>
     <p:spTree>
@@ -13532,58 +12798,34 @@
               <a:buChar char="■"/>
             </a:pPr>
             <a:r>
-              <a:rPr sz="1150" b="1">
+              <a:rPr sz="1100" b="1">
                 <a:solidFill>
                   <a:srgbClr val="0F172A"/>
                 </a:solidFill>
                 <a:latin typeface="Hiragino Sans"/>
               </a:rPr>
-              <a:t>■ 作品の形（UI・見た目・全体の構造）【必須】</a:t>
+              <a:t>作品の形（UI・見た目・全体の構造）【必須】</a:t>
             </a:r>
             <a:endParaRPr/>
           </a:p>
           <a:p>
             <a:r>
-              <a:rPr sz="980" b="0">
+              <a:rPr sz="880" b="0">
                 <a:solidFill>
                   <a:srgbClr val="1E293B"/>
                 </a:solidFill>
                 <a:latin typeface="Hiragino Sans"/>
               </a:rPr>
-              <a:t>本作品は、①【統合ホワイトボード＆ZK監査ダッシュボード（Webアプリ：md/whiteboard.html）】、②【オープン実行基盤＆標準モデル検証ハーネス（エッジ/OP-TEE連携プログラム）】、③【商品ピックアップ走行ロボットモック（マイコン制御ハードウェア＋シミュレータ）】の3要素で構成される。</a:t>
-            </a:r>
-          </a:p>
-          <a:p>
-            <a:r>
-              <a:rPr sz="950" b="0">
-                <a:solidFill>
-                  <a:srgbClr val="1E293B"/>
-                </a:solidFill>
-                <a:latin typeface="Hiragino Sans"/>
-              </a:rPr>
-              <a:t>・【画面①：インタラクティブ・アーキテクチャ＆トレースキャンバス】6つのレイヤ（収益化・分岐器・分散LLM・Lookup証明・分散チェーン・ZK保険）の計14ノードがリアルタイムに連携。レイヤ絞り込み、各モジュールの数理仕様ドロワー、Markdown/JSON仕様書出力機能を搭載。</a:t>
-            </a:r>
-          </a:p>
-          <a:p>
-            <a:r>
-              <a:rPr sz="950" b="0">
-                <a:solidFill>
-                  <a:srgbClr val="1E293B"/>
-                </a:solidFill>
-                <a:latin typeface="Hiragino Sans"/>
-              </a:rPr>
-              <a:t>・【画面②：商品ピックアップ Lookup 証明＆インジェクション遮断モック画面】悪意あるPOPを検知して遮断(CNEI/ICA)する様子と、「どの候補商品をルックアップ比較し、どの棚画像座標(Locator)を根拠に選んだか」の ZK Proof 検証結果（Verify成功・0.6秒）を視覚的に表示。</a:t>
-            </a:r>
-          </a:p>
-          <a:p>
-            <a:r>
-              <a:rPr sz="950" b="0">
-                <a:solidFill>
-                  <a:srgbClr val="1E293B"/>
-                </a:solidFill>
-                <a:latin typeface="Hiragino Sans"/>
-              </a:rPr>
-              <a:t>・【画面③：お客様・損保会社・裁判所の3視点切り替え監査ビュー】一般・損保ビューではモデル知財と個人情報が🔒墨塗り(DCSS)・暗号化されたまま約款合致を証明し、有事ビューでは3-of-5閾値合意により指定確認者（裁判所）のみが元ログを検証できる画面。</a:t>
+              <a:t>本作品は「①統合ホワイトボード＆ZK監査Webアプリ（md/whiteboard.html）」、「②オープン実行基盤＆標準モデル検証プログラム」、「③自律走行ピックアップロボットモック（Arduino制御機体＋シミュレータ）」で構成されています。
+1. [全体アーキテクチャ・キャンバス画面]
+   - ブラウザ上で6つのレイヤ（収益化・分岐器・分散LLM・Lookup証明・チェーン・保険）の14ノードが連携する図を表示
+   - レイヤごとの絞り込み、各ノードの数理仕様やCSS2026着想論文の確認、仕様書のMarkdown/JSON出力が可能
+2. [商品Lookup証明＆インジェクション遮断モック画面]
+   - 店内の偽POPを検知してCNEIゲートが赤枠で遮断するデモ画面
+   - 「候補A(小麦あり)と候補B(米粉)を比較しBを選択した」ZK Proofのリアルタイム生成・検証結果（0.6秒）を表示
+3. [3者切り替え監査ビュー（平時・有事）]
+   - お客様・損保ビュー: モデル知財と個人情報が完全に墨塗り（🔒）されたまま「約款適合」を証明
+   - 裁判所ビュー: 事故発生時に3-of-5秘密分散が揃った場合のみ指定確認者が元ログを復号検証できる画面</a:t>
             </a:r>
           </a:p>
         </p:txBody>
@@ -13684,6 +12926,217 @@
           </a:prstGeom>
         </p:spPr>
       </p:pic>
+    </p:spTree>
+  </p:cSld>
+  <p:clrMapOvr>
+    <a:masterClrMapping/>
+  </p:clrMapOvr>
+</p:sld>
+</file>
+
+<file path=ppt/slides/slide9.xml><?xml version="1.0" encoding="utf-8"?>
+<p:sld xmlns:a="http://schemas.openxmlformats.org/drawingml/2006/main" xmlns:r="http://schemas.openxmlformats.org/officeDocument/2006/relationships" xmlns:mc="http://schemas.openxmlformats.org/markup-compatibility/2006" xmlns:mv="urn:schemas-microsoft-com:mac:vml" xmlns:p="http://schemas.openxmlformats.org/presentationml/2006/main" xmlns:c="http://schemas.openxmlformats.org/drawingml/2006/chart" xmlns:dgm="http://schemas.openxmlformats.org/drawingml/2006/diagram" xmlns:o="urn:schemas-microsoft-com:office:office" xmlns:v="urn:schemas-microsoft-com:vml" xmlns:pvml="urn:schemas-microsoft-com:office:powerpoint" xmlns:com="http://schemas.openxmlformats.org/drawingml/2006/compatibility" xmlns:p14="http://schemas.microsoft.com/office/powerpoint/2010/main" xmlns:p15="http://schemas.microsoft.com/office/powerpoint/2012/main" xmlns:ahyp="http://schemas.microsoft.com/office/drawing/2018/hyperlinkcolor">
+  <p:cSld>
+    <p:spTree>
+      <p:nvGrpSpPr>
+        <p:cNvPr id="137" name="Shape 137"/>
+        <p:cNvGrpSpPr/>
+        <p:nvPr/>
+      </p:nvGrpSpPr>
+      <p:grpSpPr>
+        <a:xfrm>
+          <a:off x="0" y="0"/>
+          <a:ext cx="0" cy="0"/>
+          <a:chOff x="0" y="0"/>
+          <a:chExt cx="0" cy="0"/>
+        </a:xfrm>
+      </p:grpSpPr>
+      <p:sp>
+        <p:nvSpPr>
+          <p:cNvPr id="138" name="Google Shape;138;p24"/>
+          <p:cNvSpPr txBox="1"/>
+          <p:nvPr/>
+        </p:nvSpPr>
+        <p:spPr>
+          <a:xfrm>
+            <a:off x="393700" y="276225"/>
+            <a:ext cx="7223252" cy="257758"/>
+          </a:xfrm>
+          <a:prstGeom prst="rect">
+            <a:avLst/>
+          </a:prstGeom>
+          <a:noFill/>
+          <a:ln>
+            <a:noFill/>
+          </a:ln>
+        </p:spPr>
+        <p:txBody>
+          <a:bodyPr anchorCtr="0" anchor="t" bIns="0" lIns="0" spcFirstLastPara="1" rIns="0" wrap="square" tIns="11425">
+            <a:spAutoFit/>
+          </a:bodyPr>
+          <a:lstStyle/>
+          <a:p>
+            <a:pPr indent="0" lvl="0" marL="12700" marR="0" rtl="0" algn="l">
+              <a:lnSpc>
+                <a:spcPct val="100000"/>
+              </a:lnSpc>
+              <a:spcBef>
+                <a:spcPts val="0"/>
+              </a:spcBef>
+              <a:spcAft>
+                <a:spcPts val="0"/>
+              </a:spcAft>
+              <a:buNone/>
+            </a:pPr>
+            <a:r>
+              <a:rPr b="1" i="0" lang="ja-JP" sz="1600" u="none" cap="none" strike="noStrike">
+                <a:solidFill>
+                  <a:schemeClr val="dk1"/>
+                </a:solidFill>
+                <a:latin typeface="Meiryo"/>
+                <a:ea typeface="Meiryo"/>
+                <a:cs typeface="Meiryo"/>
+                <a:sym typeface="Meiryo"/>
+              </a:rPr>
+              <a:t>作品詳細⑦（使いやすさと見せ方の工夫）　</a:t>
+            </a:r>
+            <a:endParaRPr b="1" i="0" sz="1600" u="none" cap="none" strike="noStrike">
+              <a:solidFill>
+                <a:schemeClr val="dk1"/>
+              </a:solidFill>
+              <a:latin typeface="Meiryo"/>
+              <a:ea typeface="Meiryo"/>
+              <a:cs typeface="Meiryo"/>
+              <a:sym typeface="Meiryo"/>
+            </a:endParaRPr>
+          </a:p>
+        </p:txBody>
+      </p:sp>
+      <p:sp>
+        <p:nvSpPr>
+          <p:cNvPr id="140" name="Google Shape;140;p24"/>
+          <p:cNvSpPr txBox="1"/>
+          <p:nvPr/>
+        </p:nvSpPr>
+        <p:spPr>
+          <a:xfrm>
+            <a:off x="475996" y="1049986"/>
+            <a:ext cx="8778240" cy="5029200"/>
+          </a:xfrm>
+          <a:prstGeom prst="rect">
+            <a:avLst/>
+          </a:prstGeom>
+          <a:noFill/>
+          <a:ln>
+            <a:noFill/>
+          </a:ln>
+        </p:spPr>
+        <p:txBody>
+          <a:bodyPr anchorCtr="0" anchor="t" bIns="45700" lIns="91425" spcFirstLastPara="1" rIns="91425" wrap="square" tIns="45700">
+            <a:spAutoFit/>
+          </a:bodyPr>
+          <a:lstStyle/>
+          <a:p>
+            <a:pPr indent="-285750" lvl="0" marL="285750" marR="0" rtl="0" algn="l">
+              <a:lnSpc>
+                <a:spcPct val="100000"/>
+              </a:lnSpc>
+              <a:spcBef>
+                <a:spcPts val="0"/>
+              </a:spcBef>
+              <a:spcAft>
+                <a:spcPts val="0"/>
+              </a:spcAft>
+              <a:buClr>
+                <a:srgbClr val="000000"/>
+              </a:buClr>
+              <a:buSzPts val="1400"/>
+              <a:buFont typeface="Noto Sans Symbols"/>
+              <a:buChar char="■"/>
+            </a:pPr>
+            <a:r>
+              <a:rPr sz="1150" b="1">
+                <a:solidFill>
+                  <a:srgbClr val="0F172A"/>
+                </a:solidFill>
+                <a:latin typeface="Hiragino Sans"/>
+              </a:rPr>
+              <a:t>使いやすさと見せ方の工夫【必須】</a:t>
+            </a:r>
+            <a:endParaRPr/>
+          </a:p>
+          <a:p>
+            <a:r>
+              <a:rPr sz="900" b="0">
+                <a:solidFill>
+                  <a:srgbClr val="1E293B"/>
+                </a:solidFill>
+                <a:latin typeface="Hiragino Sans"/>
+              </a:rPr>
+              <a:t>1. 専門知識不要（信号機UIとワンタップ検証）:
+   - 高度なゼロ知識証明(ZKP)や完全準同型暗号(vFHE)の数式を裏側で自動処理
+   - 顧客スマホ画面には「✓ アレルゲン基準クリア」「✓ 個人情報マスク済」と直感的な緑色バッジと棚写真の枠線だけを表示
+2. 現場の負担ゼロ（OP-TEEによる3分岐オートメーション）:
+   - 全ての操作で人間が確認ボタンを押す必要をなくし、通常ピッキングは100%自動署名（平均670ms）
+   - 予算超過や品切れ代替品の提案時のみスマホへ通知し、不正な命令は自動遮断
+3. 視覚的で分かりやすいフィードバック:
+   - 統合ホワイトボード画面で、信号機カラー（緑＝安全、赤＝遮断、黄＝確認）を用いてシステムの稼働状況を直感的に把握可能
+4. 4者のステークホルダーに応じた専用ビュー切り替え:
+   - 店舗責任者・顧客・AI開発企業・損保会社/裁判所の4者が、自分に必要な情報だけをワンクリックで切り替えて閲覧できる設計
+5. 段階的な情報提示:
+   - まず概要サマリーを表示し、技術的な証明や暗号プロトコルを見たい部分はクリックで詳細ドロワーが展開する構造</a:t>
+            </a:r>
+          </a:p>
+        </p:txBody>
+      </p:sp>
+      <p:sp>
+        <p:nvSpPr>
+          <p:cNvPr id="141" name="Google Shape;141;p24"/>
+          <p:cNvSpPr txBox="1"/>
+          <p:nvPr>
+            <p:ph idx="12" type="sldNum"/>
+          </p:nvPr>
+        </p:nvSpPr>
+        <p:spPr>
+          <a:xfrm>
+            <a:off x="3974306" y="7194550"/>
+            <a:ext cx="2743200" cy="365125"/>
+          </a:xfrm>
+          <a:prstGeom prst="rect">
+            <a:avLst/>
+          </a:prstGeom>
+          <a:noFill/>
+          <a:ln>
+            <a:noFill/>
+          </a:ln>
+        </p:spPr>
+        <p:txBody>
+          <a:bodyPr anchorCtr="0" anchor="ctr" bIns="45700" lIns="91425" spcFirstLastPara="1" rIns="91425" wrap="square" tIns="45700">
+            <a:noAutofit/>
+          </a:bodyPr>
+          <a:lstStyle/>
+          <a:p>
+            <a:pPr indent="0" lvl="0" marL="0" rtl="0" algn="ctr">
+              <a:lnSpc>
+                <a:spcPct val="100000"/>
+              </a:lnSpc>
+              <a:spcBef>
+                <a:spcPts val="0"/>
+              </a:spcBef>
+              <a:spcAft>
+                <a:spcPts val="0"/>
+              </a:spcAft>
+              <a:buSzPts val="700"/>
+              <a:buNone/>
+            </a:pPr>
+            <a:fld id="{00000000-1234-1234-1234-123412341234}" type="slidenum">
+              <a:rPr lang="ja-JP"/>
+              <a:t>‹#›</a:t>
+            </a:fld>
+            <a:endParaRPr/>
+          </a:p>
+        </p:txBody>
+      </p:sp>
     </p:spTree>
   </p:cSld>
   <p:clrMapOvr>

</xml_diff>

<commit_message>
docs(pptx): Align entry sheet with team roles, implementation roadmap, and slide repository links
</commit_message>
<xml_diff>
--- a/md/zenjyocon_entry_sheet_2026.pptx
+++ b/md/zenjyocon_entry_sheet_2026.pptx
@@ -8566,7 +8566,7 @@
                           </a:solidFill>
                           <a:latin typeface="Hiragino Sans"/>
                         </a:rPr>
-                        <a:t>Project ProofPick</a:t>
+                        <a:t>Project ProofPick（分散AI・暗号監査ロボティクス探究班）</a:t>
                       </a:r>
                       <a:endParaRPr sz="1400" u="none" cap="none" strike="noStrike">
                         <a:solidFill>
@@ -8920,13 +8920,13 @@
                         <a:buNone/>
                       </a:pPr>
                       <a:r>
-                        <a:rPr sz="1100" b="0">
+                        <a:rPr sz="1050" b="0">
                           <a:solidFill>
                             <a:srgbClr val="0F172A"/>
                           </a:solidFill>
                           <a:latin typeface="Hiragino Sans"/>
                         </a:rPr>
-                        <a:t>米川 明希</a:t>
+                        <a:t>米川 明希、吉田 創也、はいまい、棚橋 弘（暗号回路設計リード）</a:t>
                       </a:r>
                       <a:endParaRPr sz="1400" u="none" cap="none" strike="noStrike">
                         <a:solidFill>
@@ -9268,7 +9268,7 @@
           </a:p>
           <a:p>
             <a:r>
-              <a:rPr sz="900" b="0">
+              <a:rPr sz="880" b="0">
                 <a:solidFill>
                   <a:srgbClr val="1E293B"/>
                 </a:solidFill>
@@ -9276,7 +9276,7 @@
               </a:rPr>
               <a:t>1. 暗号プログラムでのグループ議論: AIエージェントの運用実績(task, trace)を機密非開示で損保に証明する保険モデルとvFHE(ZK+FHE)を設計
 2. 学会論文調査(CSS2026): プロンプトインジェクション防御(ASIDE+ICA)、Random Forest分岐器トリアージ、VLA動的チャンク制御、証跡Locatorの決定論的Lint、指定確認者墨塗署名(DCSS)の最新手法を分析
-3. プロトタイプ検証: 分岐器によるLLM呼出23%削減、OP-TEEでの自動署名670ms、DCSS墨塗り検証0.58msの実効性を確認</a:t>
+3. チーム役割分担とエンジニア実装: 暗号回路設計を核（7割牽引）とし、はいまいくんがロボット制御とMPCエンドポイント、米川くん・吉田くんが分岐器トリアージとPIIマスクWeb基盤を実装。プロトタイプで呼出23%削減・自動署名670ms・DCSS検証0.58msを確認</a:t>
             </a:r>
           </a:p>
           <a:p>
@@ -9344,7 +9344,7 @@
                 </a:solidFill>
                 <a:latin typeface="Hiragino Sans"/>
               </a:rPr>
-              <a:t>1. 実店舗・実倉庫での走行実験: 実際のスーパー棚と物流テストコースで複数ロボットを走らせ、ピッキング速度と安全性を評価
+              <a:t>1. 2026年11月10日提出後の実証実験: 実際のスーパー棚と物流テストコースで複数ロボットを走らせ、ピッキング速度と安全性を評価
 2. 損保会社との共同実証: 実際の保険約款を取り込み、ZK証明を用いた自動保険料割引と事故時即時支払いのパイロット運用
 3. 異種ロボット間P2Pリソース融通: 通路混雑情報や充電枠をロボット同士で自律的に売買・融通する経済圏の実装</a:t>
             </a:r>
@@ -12579,21 +12579,21 @@
               <a:t>1. [注文受付・PII事前マスク]
    - スマホから注文データを受信、店内カメラが棚画像を取得
    - 定型個人情報は正規表現で即座にマスク、曖昧な箇所のみローカルLLMで補正
-2. [分岐器トリアージによるルーティング]
+2. [分岐器トリアージによるルーティング (米川・吉田担当)]
    - 定型的な商品指定の場合、LLMを呼ばずに直接Lookup処理へジャンプ（呼出23%削減）
    - 複雑な注文のみ、ASIDE+ICA防御が有効化された分散LLMへ送信
-3. [推論と物理制御の安定化（繰り返しループ）]
+3. [推論と物理制御の安定化（繰り返しループ：はいまい担当）]
    - 店内POPの悪意ある命令を動的ゲートで遮断しながら商品候補を推論
    - ロボット移動時、未実行行動列との割引累積不一致度を毎ステップ監視。異常検知時は実行長を1に短縮し減速
-4. [商品Lookup検討と証跡記録]
+4. [商品Lookup検討と証跡記録（暗号回路設計担当）]
    - 店舗の正規商品テーブル(LUT)から候補商品を比較検討（アレルギー・価格・鮮度）
    - 根拠となった棚画像座標(image_bbox)を三層バンドルに記録し、決定論的Lintで不整合を検査（違反0%強制）
 5. [TEEモデル外強制と署名判断（条件分岐）]
-   - CNEIゲートが要求上限 Level(a) ≤ τ を照合。不正な要求超過操作はfail-closedで即座に遮断
+   - CNEIゲートが操作上限を確認。不正な要求超過操作はfail-closedで即座に遮断
    - ポリシー適合時はOP-TEE内で自動署名(670ms)、予算超過時はユーザー確認へ分岐、形式不正は拒否
 6. [ピックアップ実行・報酬決済・保険監査]
    - 商品をピッキングし、ZK Lookup証明とProgress Receiptを発行
-   - コンソーシアムチェーンでロボットへ報酬を支払い、平時はZK無開示監査、有事はDCSSで裁判所が開示検証</a:t>
+   - コンソーシアムチェーンでロボットへ報酬を支払い、平時はZK無開示査定、有事はDCSSで裁判所が開示検証</a:t>
             </a:r>
           </a:p>
           <a:p>
@@ -12604,7 +12604,7 @@
                 </a:solidFill>
                 <a:latin typeface="Hiragino Sans"/>
               </a:rPr>
-              <a:t>ソースコード格納先【任意】</a:t>
+              <a:t>ソースコード・設計スライド格納先【任意】</a:t>
             </a:r>
           </a:p>
           <a:p>
@@ -12615,8 +12615,8 @@
                 </a:solidFill>
                 <a:latin typeface="Hiragino Sans"/>
               </a:rPr>
-              <a:t>https://github.com/sururu-k/ProofPick
-ホワイトボード画面（md/whiteboard.html）、ロボット制御プログラム、暗号検証モックコード一式を格納しています</a:t>
+              <a:t>・製品計画・技術説明スライド: https://github.com/hirorogo/slides （ProofPickスライド）
+・実行基盤コード・ホワイトボード: https://github.com/sururu-k/ProofPick （docs/STRATEGY.md参照）</a:t>
             </a:r>
           </a:p>
         </p:txBody>

</xml_diff>

<commit_message>
fix(docs): Correct member name to Imai across strategy and entry sheet
</commit_message>
<xml_diff>
--- a/md/zenjyocon_entry_sheet_2026.pptx
+++ b/md/zenjyocon_entry_sheet_2026.pptx
@@ -8926,7 +8926,7 @@
                           </a:solidFill>
                           <a:latin typeface="Hiragino Sans"/>
                         </a:rPr>
-                        <a:t>米川 明希、吉田 創也、はいまい、棚橋 弘（暗号回路設計リード）</a:t>
+                        <a:t>米川 明希、吉田 創也、今井、棚橋 弘（暗号回路設計リード）</a:t>
                       </a:r>
                       <a:endParaRPr sz="1400" u="none" cap="none" strike="noStrike">
                         <a:solidFill>
@@ -9276,7 +9276,7 @@
               </a:rPr>
               <a:t>1. 暗号プログラムでのグループ議論: AIエージェントの運用実績(task, trace)を機密非開示で損保に証明する保険モデルとvFHE(ZK+FHE)を設計
 2. 学会論文調査(CSS2026): プロンプトインジェクション防御(ASIDE+ICA)、Random Forest分岐器トリアージ、VLA動的チャンク制御、証跡Locatorの決定論的Lint、指定確認者墨塗署名(DCSS)の最新手法を分析
-3. チーム役割分担とエンジニア実装: 暗号回路設計を核（7割牽引）とし、はいまいくんがロボット制御とMPCエンドポイント、米川くん・吉田くんが分岐器トリアージとPIIマスクWeb基盤を実装。プロトタイプで呼出23%削減・自動署名670ms・DCSS検証0.58msを確認</a:t>
+3. チーム役割分担とエンジニア実装: 暗号回路設計を核（7割牽引）とし、今井くんがロボット制御とMPCエンドポイント、米川くん・吉田くんが分岐器トリアージとPIIマスクWeb基盤を実装。プロトタイプで呼出23%削減・自動署名670ms・DCSS検証0.58msを確認</a:t>
             </a:r>
           </a:p>
           <a:p>
@@ -12582,7 +12582,7 @@
 2. [分岐器トリアージによるルーティング (米川・吉田担当)]
    - 定型的な商品指定の場合、LLMを呼ばずに直接Lookup処理へジャンプ（呼出23%削減）
    - 複雑な注文のみ、ASIDE+ICA防御が有効化された分散LLMへ送信
-3. [推論と物理制御の安定化（繰り返しループ：はいまい担当）]
+3. [推論と物理制御の安定化（繰り返しループ：今井担当）]
    - 店内POPの悪意ある命令を動的ゲートで遮断しながら商品候補を推論
    - ロボット移動時、未実行行動列との割引累積不一致度を毎ステップ監視。異常検知時は実行長を1に短縮し減速
 4. [商品Lookup検討と証跡記録（暗号回路設計担当）]

</xml_diff>